<commit_message>
Fix: treat binaries as binary (.gitattributes); restore intact PPTX
</commit_message>
<xml_diff>
--- a/results/presentation/OHT_MAPF_presentation.pptx
+++ b/results/presentation/OHT_MAPF_presentation.pptx
@@ -4,9 +4,6 @@
   <p:sldMasterIdLst>
     <p:sldMasterId id="2147483648" r:id="rId1"/>
   </p:sldMasterIdLst>
-  <p:notesMasterIdLst>
-    <p:notesMasterId r:id="rId31"/>
-  </p:notesMasterIdLst>
   <p:sldIdLst>
     <p:sldId id="256" r:id="rId2"/>
     <p:sldId id="257" r:id="rId3"/>
@@ -38,6 +35,9 @@
     <p:sldId id="283" r:id="rId29"/>
     <p:sldId id="284" r:id="rId30"/>
   </p:sldIdLst>
+  <p:notesMasterIdLst>
+    <p:notesMasterId r:id="rId31"/>
+  </p:notesMasterIdLst>
   <p:sldSz cx="12192000" cy="6858000"/>
   <p:notesSz cx="6858000" cy="12192000"/>
   <p:defaultTextStyle>
@@ -132,11 +132,6 @@
       </a:defRPr>
     </a:lvl9pPr>
   </p:defaultTextStyle>
-  <p:extLst>
-    <p:ext uri="{EFAFB233-063F-42B5-8137-9DF3F51BA10A}">
-      <p15:sldGuideLst xmlns:p15="http://schemas.microsoft.com/office/powerpoint/2012/main"/>
-    </p:ext>
-  </p:extLst>
 </p:presentation>
 </file>
 
@@ -162,16 +157,240 @@
           <a:chExt cx="0" cy="0"/>
         </a:xfrm>
       </p:grpSpPr>
+      <p:sp>
+        <p:nvSpPr>
+          <p:cNvPr id="2" name="Header Placeholder 1"/>
+          <p:cNvSpPr>
+            <a:spLocks noGrp="1"/>
+          </p:cNvSpPr>
+          <p:nvPr>
+            <p:ph type="hdr" sz="quarter"/>
+          </p:nvPr>
+        </p:nvSpPr>
+        <p:spPr>
+          <a:xfrm>
+            <a:off x="0" y="0"/>
+            <a:ext cx="2971800" cy="458788"/>
+          </a:xfrm>
+          <a:prstGeom prst="rect">
+            <a:avLst/>
+          </a:prstGeom>
+        </p:spPr>
+        <p:txBody>
+          <a:bodyPr vert="horz" lIns="91440" tIns="45720" rIns="91440" bIns="45720" rtlCol="0"/>
+          <a:lstStyle>
+            <a:lvl1pPr algn="l">
+              <a:defRPr sz="1200"/>
+            </a:lvl1pPr>
+          </a:lstStyle>
+          <a:p>
+            <a:endParaRPr lang="en-US"/>
+          </a:p>
+        </p:txBody>
+      </p:sp>
+      <p:sp>
+        <p:nvSpPr>
+          <p:cNvPr id="3" name="Date Placeholder 2"/>
+          <p:cNvSpPr>
+            <a:spLocks noGrp="1"/>
+          </p:cNvSpPr>
+          <p:nvPr>
+            <p:ph type="dt" idx="1"/>
+          </p:nvPr>
+        </p:nvSpPr>
+        <p:spPr>
+          <a:xfrm>
+            <a:off x="3884613" y="0"/>
+            <a:ext cx="2971800" cy="458788"/>
+          </a:xfrm>
+          <a:prstGeom prst="rect">
+            <a:avLst/>
+          </a:prstGeom>
+        </p:spPr>
+        <p:txBody>
+          <a:bodyPr vert="horz" lIns="91440" tIns="45720" rIns="91440" bIns="45720" rtlCol="0"/>
+          <a:lstStyle>
+            <a:lvl1pPr algn="r">
+              <a:defRPr sz="1200"/>
+            </a:lvl1pPr>
+          </a:lstStyle>
+          <a:p>
+            <a:fld id="{5282F153-3F37-0F45-9E97-73ACFA13230C}" type="datetimeFigureOut">
+              <a:rPr lang="en-US"/>
+              <a:t>7/23/19</a:t>
+            </a:fld>
+            <a:endParaRPr lang="en-US"/>
+          </a:p>
+        </p:txBody>
+      </p:sp>
+      <p:sp>
+        <p:nvSpPr>
+          <p:cNvPr id="4" name="Slide Image Placeholder 3"/>
+          <p:cNvSpPr>
+            <a:spLocks noGrp="1" noRot="1" noChangeAspect="1"/>
+          </p:cNvSpPr>
+          <p:nvPr>
+            <p:ph type="sldImg" idx="2"/>
+          </p:nvPr>
+        </p:nvSpPr>
+        <p:spPr>
+          <a:xfrm>
+            <a:off x="685800" y="1143000"/>
+            <a:ext cx="5486400" cy="3086100"/>
+          </a:xfrm>
+          <a:prstGeom prst="rect">
+            <a:avLst/>
+          </a:prstGeom>
+          <a:noFill/>
+          <a:ln w="12700">
+            <a:solidFill>
+              <a:prstClr val="black"/>
+            </a:solidFill>
+          </a:ln>
+        </p:spPr>
+        <p:txBody>
+          <a:bodyPr vert="horz" lIns="91440" tIns="45720" rIns="91440" bIns="45720" rtlCol="0" anchor="ctr"/>
+          <a:lstStyle/>
+          <a:p>
+            <a:endParaRPr lang="en-US"/>
+          </a:p>
+        </p:txBody>
+      </p:sp>
+      <p:sp>
+        <p:nvSpPr>
+          <p:cNvPr id="5" name="Notes Placeholder 4"/>
+          <p:cNvSpPr>
+            <a:spLocks noGrp="1"/>
+          </p:cNvSpPr>
+          <p:nvPr>
+            <p:ph type="body" sz="quarter" idx="3"/>
+          </p:nvPr>
+        </p:nvSpPr>
+        <p:spPr>
+          <a:xfrm>
+            <a:off x="685800" y="4400550"/>
+            <a:ext cx="5486400" cy="3600450"/>
+          </a:xfrm>
+          <a:prstGeom prst="rect">
+            <a:avLst/>
+          </a:prstGeom>
+        </p:spPr>
+        <p:txBody>
+          <a:bodyPr vert="horz" lIns="91440" tIns="45720" rIns="91440" bIns="45720" rtlCol="0"/>
+          <a:lstStyle/>
+          <a:p>
+            <a:pPr lvl="0"/>
+            <a:r>
+              <a:rPr lang="en-US"/>
+              <a:t>Click to edit Master text styles</a:t>
+            </a:r>
+          </a:p>
+          <a:p>
+            <a:pPr lvl="1"/>
+            <a:r>
+              <a:rPr lang="en-US"/>
+              <a:t>Second level</a:t>
+            </a:r>
+          </a:p>
+          <a:p>
+            <a:pPr lvl="2"/>
+            <a:r>
+              <a:rPr lang="en-US"/>
+              <a:t>Third level</a:t>
+            </a:r>
+          </a:p>
+          <a:p>
+            <a:pPr lvl="3"/>
+            <a:r>
+              <a:rPr lang="en-US"/>
+              <a:t>Fourth level</a:t>
+            </a:r>
+          </a:p>
+          <a:p>
+            <a:pPr lvl="4"/>
+            <a:r>
+              <a:rPr lang="en-US"/>
+              <a:t>Fifth level</a:t>
+            </a:r>
+          </a:p>
+        </p:txBody>
+      </p:sp>
+      <p:sp>
+        <p:nvSpPr>
+          <p:cNvPr id="6" name="Footer Placeholder 5"/>
+          <p:cNvSpPr>
+            <a:spLocks noGrp="1"/>
+          </p:cNvSpPr>
+          <p:nvPr>
+            <p:ph type="ftr" sz="quarter" idx="4"/>
+          </p:nvPr>
+        </p:nvSpPr>
+        <p:spPr>
+          <a:xfrm>
+            <a:off x="0" y="8685213"/>
+            <a:ext cx="2971800" cy="458787"/>
+          </a:xfrm>
+          <a:prstGeom prst="rect">
+            <a:avLst/>
+          </a:prstGeom>
+        </p:spPr>
+        <p:txBody>
+          <a:bodyPr vert="horz" lIns="91440" tIns="45720" rIns="91440" bIns="45720" rtlCol="0" anchor="b"/>
+          <a:lstStyle>
+            <a:lvl1pPr algn="l">
+              <a:defRPr sz="1200"/>
+            </a:lvl1pPr>
+          </a:lstStyle>
+          <a:p>
+            <a:endParaRPr lang="en-US"/>
+          </a:p>
+        </p:txBody>
+      </p:sp>
+      <p:sp>
+        <p:nvSpPr>
+          <p:cNvPr id="7" name="Slide Number Placeholder 6"/>
+          <p:cNvSpPr>
+            <a:spLocks noGrp="1"/>
+          </p:cNvSpPr>
+          <p:nvPr>
+            <p:ph type="sldNum" sz="quarter" idx="5"/>
+          </p:nvPr>
+        </p:nvSpPr>
+        <p:spPr>
+          <a:xfrm>
+            <a:off x="3884613" y="8685213"/>
+            <a:ext cx="2971800" cy="458787"/>
+          </a:xfrm>
+          <a:prstGeom prst="rect">
+            <a:avLst/>
+          </a:prstGeom>
+        </p:spPr>
+        <p:txBody>
+          <a:bodyPr vert="horz" lIns="91440" tIns="45720" rIns="91440" bIns="45720" rtlCol="0" anchor="b"/>
+          <a:lstStyle>
+            <a:lvl1pPr algn="r">
+              <a:defRPr sz="1200"/>
+            </a:lvl1pPr>
+          </a:lstStyle>
+          <a:p>
+            <a:fld id="{CE5E9CC1-C706-0F49-92D6-E571CC5EEA8F}" type="slidenum">
+              <a:rPr lang="en-US"/>
+              <a:t>‹#›</a:t>
+            </a:fld>
+            <a:endParaRPr lang="en-US"/>
+          </a:p>
+        </p:txBody>
+      </p:sp>
     </p:spTree>
     <p:extLst>
       <p:ext uri="{BB962C8B-B14F-4D97-AF65-F5344CB8AC3E}">
-        <p14:creationId xmlns:p14="http://schemas.microsoft.com/office/powerpoint/2010/main" val="1120935634"/>
+        <p14:creationId xmlns:p14="http://schemas.microsoft.com/office/powerpoint/2010/main" val="1024086991"/>
       </p:ext>
     </p:extLst>
   </p:cSld>
   <p:clrMap bg1="lt1" tx1="dk1" bg2="lt2" tx2="dk2" accent1="accent1" accent2="accent2" accent3="accent3" accent4="accent4" accent5="accent5" accent6="accent6" hlink="hlink" folHlink="folHlink"/>
   <p:notesStyle>
-    <a:lvl1pPr marL="0" algn="l" defTabSz="914400" rtl="0" eaLnBrk="1" latinLnBrk="1" hangingPunct="1">
+    <a:lvl1pPr marL="0" algn="l" defTabSz="914400" rtl="0" eaLnBrk="1" latinLnBrk="0" hangingPunct="1">
       <a:defRPr sz="1200" kern="1200">
         <a:solidFill>
           <a:schemeClr val="tx1"/>
@@ -181,7 +400,7 @@
         <a:cs typeface="+mn-cs"/>
       </a:defRPr>
     </a:lvl1pPr>
-    <a:lvl2pPr marL="457200" algn="l" defTabSz="914400" rtl="0" eaLnBrk="1" latinLnBrk="1" hangingPunct="1">
+    <a:lvl2pPr marL="457200" algn="l" defTabSz="914400" rtl="0" eaLnBrk="1" latinLnBrk="0" hangingPunct="1">
       <a:defRPr sz="1200" kern="1200">
         <a:solidFill>
           <a:schemeClr val="tx1"/>
@@ -191,7 +410,7 @@
         <a:cs typeface="+mn-cs"/>
       </a:defRPr>
     </a:lvl2pPr>
-    <a:lvl3pPr marL="914400" algn="l" defTabSz="914400" rtl="0" eaLnBrk="1" latinLnBrk="1" hangingPunct="1">
+    <a:lvl3pPr marL="914400" algn="l" defTabSz="914400" rtl="0" eaLnBrk="1" latinLnBrk="0" hangingPunct="1">
       <a:defRPr sz="1200" kern="1200">
         <a:solidFill>
           <a:schemeClr val="tx1"/>
@@ -201,7 +420,7 @@
         <a:cs typeface="+mn-cs"/>
       </a:defRPr>
     </a:lvl3pPr>
-    <a:lvl4pPr marL="1371600" algn="l" defTabSz="914400" rtl="0" eaLnBrk="1" latinLnBrk="1" hangingPunct="1">
+    <a:lvl4pPr marL="1371600" algn="l" defTabSz="914400" rtl="0" eaLnBrk="1" latinLnBrk="0" hangingPunct="1">
       <a:defRPr sz="1200" kern="1200">
         <a:solidFill>
           <a:schemeClr val="tx1"/>
@@ -211,7 +430,7 @@
         <a:cs typeface="+mn-cs"/>
       </a:defRPr>
     </a:lvl4pPr>
-    <a:lvl5pPr marL="1828800" algn="l" defTabSz="914400" rtl="0" eaLnBrk="1" latinLnBrk="1" hangingPunct="1">
+    <a:lvl5pPr marL="1828800" algn="l" defTabSz="914400" rtl="0" eaLnBrk="1" latinLnBrk="0" hangingPunct="1">
       <a:defRPr sz="1200" kern="1200">
         <a:solidFill>
           <a:schemeClr val="tx1"/>
@@ -221,7 +440,7 @@
         <a:cs typeface="+mn-cs"/>
       </a:defRPr>
     </a:lvl5pPr>
-    <a:lvl6pPr marL="2286000" algn="l" defTabSz="914400" rtl="0" eaLnBrk="1" latinLnBrk="1" hangingPunct="1">
+    <a:lvl6pPr marL="2286000" algn="l" defTabSz="914400" rtl="0" eaLnBrk="1" latinLnBrk="0" hangingPunct="1">
       <a:defRPr sz="1200" kern="1200">
         <a:solidFill>
           <a:schemeClr val="tx1"/>
@@ -231,7 +450,7 @@
         <a:cs typeface="+mn-cs"/>
       </a:defRPr>
     </a:lvl6pPr>
-    <a:lvl7pPr marL="2743200" algn="l" defTabSz="914400" rtl="0" eaLnBrk="1" latinLnBrk="1" hangingPunct="1">
+    <a:lvl7pPr marL="2743200" algn="l" defTabSz="914400" rtl="0" eaLnBrk="1" latinLnBrk="0" hangingPunct="1">
       <a:defRPr sz="1200" kern="1200">
         <a:solidFill>
           <a:schemeClr val="tx1"/>
@@ -241,7 +460,7 @@
         <a:cs typeface="+mn-cs"/>
       </a:defRPr>
     </a:lvl7pPr>
-    <a:lvl8pPr marL="3200400" algn="l" defTabSz="914400" rtl="0" eaLnBrk="1" latinLnBrk="1" hangingPunct="1">
+    <a:lvl8pPr marL="3200400" algn="l" defTabSz="914400" rtl="0" eaLnBrk="1" latinLnBrk="0" hangingPunct="1">
       <a:defRPr sz="1200" kern="1200">
         <a:solidFill>
           <a:schemeClr val="tx1"/>
@@ -251,7 +470,7 @@
         <a:cs typeface="+mn-cs"/>
       </a:defRPr>
     </a:lvl8pPr>
-    <a:lvl9pPr marL="3657600" algn="l" defTabSz="914400" rtl="0" eaLnBrk="1" latinLnBrk="1" hangingPunct="1">
+    <a:lvl9pPr marL="3657600" algn="l" defTabSz="914400" rtl="0" eaLnBrk="1" latinLnBrk="0" hangingPunct="1">
       <a:defRPr sz="1200" kern="1200">
         <a:solidFill>
           <a:schemeClr val="tx1"/>
@@ -309,6 +528,10 @@
           <a:bodyPr/>
           <a:lstStyle/>
           <a:p>
+            <a:r>
+              <a:rPr lang="en-US" dirty="0"/>
+              <a:t/>
+            </a:r>
             <a:endParaRPr lang="en-US" dirty="0"/>
           </a:p>
         </p:txBody>
@@ -393,6 +616,10 @@
           <a:bodyPr/>
           <a:lstStyle/>
           <a:p>
+            <a:r>
+              <a:rPr lang="en-US" dirty="0"/>
+              <a:t/>
+            </a:r>
             <a:endParaRPr lang="en-US" dirty="0"/>
           </a:p>
         </p:txBody>
@@ -477,6 +704,10 @@
           <a:bodyPr/>
           <a:lstStyle/>
           <a:p>
+            <a:r>
+              <a:rPr lang="en-US" dirty="0"/>
+              <a:t/>
+            </a:r>
             <a:endParaRPr lang="en-US" dirty="0"/>
           </a:p>
         </p:txBody>
@@ -561,6 +792,10 @@
           <a:bodyPr/>
           <a:lstStyle/>
           <a:p>
+            <a:r>
+              <a:rPr lang="en-US" dirty="0"/>
+              <a:t/>
+            </a:r>
             <a:endParaRPr lang="en-US" dirty="0"/>
           </a:p>
         </p:txBody>
@@ -645,6 +880,10 @@
           <a:bodyPr/>
           <a:lstStyle/>
           <a:p>
+            <a:r>
+              <a:rPr lang="en-US" dirty="0"/>
+              <a:t/>
+            </a:r>
             <a:endParaRPr lang="en-US" dirty="0"/>
           </a:p>
         </p:txBody>
@@ -729,6 +968,10 @@
           <a:bodyPr/>
           <a:lstStyle/>
           <a:p>
+            <a:r>
+              <a:rPr lang="en-US" dirty="0"/>
+              <a:t/>
+            </a:r>
             <a:endParaRPr lang="en-US" dirty="0"/>
           </a:p>
         </p:txBody>
@@ -813,6 +1056,10 @@
           <a:bodyPr/>
           <a:lstStyle/>
           <a:p>
+            <a:r>
+              <a:rPr lang="en-US" dirty="0"/>
+              <a:t/>
+            </a:r>
             <a:endParaRPr lang="en-US" dirty="0"/>
           </a:p>
         </p:txBody>
@@ -897,6 +1144,10 @@
           <a:bodyPr/>
           <a:lstStyle/>
           <a:p>
+            <a:r>
+              <a:rPr lang="en-US" dirty="0"/>
+              <a:t/>
+            </a:r>
             <a:endParaRPr lang="en-US" dirty="0"/>
           </a:p>
         </p:txBody>
@@ -981,6 +1232,10 @@
           <a:bodyPr/>
           <a:lstStyle/>
           <a:p>
+            <a:r>
+              <a:rPr lang="en-US" dirty="0"/>
+              <a:t/>
+            </a:r>
             <a:endParaRPr lang="en-US" dirty="0"/>
           </a:p>
         </p:txBody>
@@ -1065,6 +1320,10 @@
           <a:bodyPr/>
           <a:lstStyle/>
           <a:p>
+            <a:r>
+              <a:rPr lang="en-US" dirty="0"/>
+              <a:t/>
+            </a:r>
             <a:endParaRPr lang="en-US" dirty="0"/>
           </a:p>
         </p:txBody>
@@ -1149,6 +1408,10 @@
           <a:bodyPr/>
           <a:lstStyle/>
           <a:p>
+            <a:r>
+              <a:rPr lang="en-US" dirty="0"/>
+              <a:t/>
+            </a:r>
             <a:endParaRPr lang="en-US" dirty="0"/>
           </a:p>
         </p:txBody>
@@ -1233,6 +1496,10 @@
           <a:bodyPr/>
           <a:lstStyle/>
           <a:p>
+            <a:r>
+              <a:rPr lang="en-US" dirty="0"/>
+              <a:t/>
+            </a:r>
             <a:endParaRPr lang="en-US" dirty="0"/>
           </a:p>
         </p:txBody>
@@ -1317,6 +1584,10 @@
           <a:bodyPr/>
           <a:lstStyle/>
           <a:p>
+            <a:r>
+              <a:rPr lang="en-US" dirty="0"/>
+              <a:t/>
+            </a:r>
             <a:endParaRPr lang="en-US" dirty="0"/>
           </a:p>
         </p:txBody>
@@ -1401,6 +1672,10 @@
           <a:bodyPr/>
           <a:lstStyle/>
           <a:p>
+            <a:r>
+              <a:rPr lang="en-US" dirty="0"/>
+              <a:t/>
+            </a:r>
             <a:endParaRPr lang="en-US" dirty="0"/>
           </a:p>
         </p:txBody>
@@ -1485,6 +1760,10 @@
           <a:bodyPr/>
           <a:lstStyle/>
           <a:p>
+            <a:r>
+              <a:rPr lang="en-US" dirty="0"/>
+              <a:t/>
+            </a:r>
             <a:endParaRPr lang="en-US" dirty="0"/>
           </a:p>
         </p:txBody>
@@ -1569,6 +1848,10 @@
           <a:bodyPr/>
           <a:lstStyle/>
           <a:p>
+            <a:r>
+              <a:rPr lang="en-US" dirty="0"/>
+              <a:t/>
+            </a:r>
             <a:endParaRPr lang="en-US" dirty="0"/>
           </a:p>
         </p:txBody>
@@ -1653,6 +1936,10 @@
           <a:bodyPr/>
           <a:lstStyle/>
           <a:p>
+            <a:r>
+              <a:rPr lang="en-US" dirty="0"/>
+              <a:t/>
+            </a:r>
             <a:endParaRPr lang="en-US" dirty="0"/>
           </a:p>
         </p:txBody>
@@ -1737,6 +2024,10 @@
           <a:bodyPr/>
           <a:lstStyle/>
           <a:p>
+            <a:r>
+              <a:rPr lang="en-US" dirty="0"/>
+              <a:t/>
+            </a:r>
             <a:endParaRPr lang="en-US" dirty="0"/>
           </a:p>
         </p:txBody>
@@ -1821,6 +2112,10 @@
           <a:bodyPr/>
           <a:lstStyle/>
           <a:p>
+            <a:r>
+              <a:rPr lang="en-US" dirty="0"/>
+              <a:t/>
+            </a:r>
             <a:endParaRPr lang="en-US" dirty="0"/>
           </a:p>
         </p:txBody>
@@ -1905,6 +2200,10 @@
           <a:bodyPr/>
           <a:lstStyle/>
           <a:p>
+            <a:r>
+              <a:rPr lang="en-US" dirty="0"/>
+              <a:t/>
+            </a:r>
             <a:endParaRPr lang="en-US" dirty="0"/>
           </a:p>
         </p:txBody>
@@ -1989,6 +2288,10 @@
           <a:bodyPr/>
           <a:lstStyle/>
           <a:p>
+            <a:r>
+              <a:rPr lang="en-US" dirty="0"/>
+              <a:t/>
+            </a:r>
             <a:endParaRPr lang="en-US" dirty="0"/>
           </a:p>
         </p:txBody>
@@ -2073,6 +2376,10 @@
           <a:bodyPr/>
           <a:lstStyle/>
           <a:p>
+            <a:r>
+              <a:rPr lang="en-US" dirty="0"/>
+              <a:t/>
+            </a:r>
             <a:endParaRPr lang="en-US" dirty="0"/>
           </a:p>
         </p:txBody>
@@ -2157,6 +2464,10 @@
           <a:bodyPr/>
           <a:lstStyle/>
           <a:p>
+            <a:r>
+              <a:rPr lang="en-US" dirty="0"/>
+              <a:t/>
+            </a:r>
             <a:endParaRPr lang="en-US" dirty="0"/>
           </a:p>
         </p:txBody>
@@ -2241,6 +2552,10 @@
           <a:bodyPr/>
           <a:lstStyle/>
           <a:p>
+            <a:r>
+              <a:rPr lang="en-US" dirty="0"/>
+              <a:t/>
+            </a:r>
             <a:endParaRPr lang="en-US" dirty="0"/>
           </a:p>
         </p:txBody>
@@ -2325,6 +2640,10 @@
           <a:bodyPr/>
           <a:lstStyle/>
           <a:p>
+            <a:r>
+              <a:rPr lang="en-US" dirty="0"/>
+              <a:t/>
+            </a:r>
             <a:endParaRPr lang="en-US" dirty="0"/>
           </a:p>
         </p:txBody>
@@ -2409,6 +2728,10 @@
           <a:bodyPr/>
           <a:lstStyle/>
           <a:p>
+            <a:r>
+              <a:rPr lang="en-US" dirty="0"/>
+              <a:t/>
+            </a:r>
             <a:endParaRPr lang="en-US" dirty="0"/>
           </a:p>
         </p:txBody>
@@ -2493,6 +2816,10 @@
           <a:bodyPr/>
           <a:lstStyle/>
           <a:p>
+            <a:r>
+              <a:rPr lang="en-US" dirty="0"/>
+              <a:t/>
+            </a:r>
             <a:endParaRPr lang="en-US" dirty="0"/>
           </a:p>
         </p:txBody>
@@ -2577,6 +2904,10 @@
           <a:bodyPr/>
           <a:lstStyle/>
           <a:p>
+            <a:r>
+              <a:rPr lang="en-US" dirty="0"/>
+              <a:t/>
+            </a:r>
             <a:endParaRPr lang="en-US" dirty="0"/>
           </a:p>
         </p:txBody>
@@ -2661,6 +2992,10 @@
           <a:bodyPr/>
           <a:lstStyle/>
           <a:p>
+            <a:r>
+              <a:rPr lang="en-US" dirty="0"/>
+              <a:t/>
+            </a:r>
             <a:endParaRPr lang="en-US" dirty="0"/>
           </a:p>
         </p:txBody>
@@ -2734,11 +3069,6 @@
 <file path=ppt/slideMasters/slideMaster1.xml><?xml version="1.0" encoding="utf-8"?>
 <p:sldMaster xmlns:a="http://schemas.openxmlformats.org/drawingml/2006/main" xmlns:r="http://schemas.openxmlformats.org/officeDocument/2006/relationships" xmlns:p="http://schemas.openxmlformats.org/presentationml/2006/main">
   <p:cSld>
-    <p:bg>
-      <p:bgRef idx="1001">
-        <a:schemeClr val="bg1"/>
-      </p:bgRef>
-    </p:bg>
     <p:spTree>
       <p:nvGrpSpPr>
         <p:cNvPr id="1" name=""/>
@@ -3021,7 +3351,6 @@
         <a:solidFill>
           <a:srgbClr val="FFFFFF"/>
         </a:solidFill>
-        <a:effectLst/>
       </p:bgPr>
     </p:bg>
     <p:spTree>
@@ -3059,7 +3388,7 @@
           <a:bodyPr wrap="square" lIns="0" tIns="0" rIns="0" bIns="0" rtlCol="0" anchor="ctr"/>
           <a:lstStyle/>
           <a:p>
-            <a:pPr marL="0" indent="0">
+            <a:pPr indent="0" marL="0">
               <a:buNone/>
             </a:pPr>
             <a:r>
@@ -3098,7 +3427,7 @@
           <a:bodyPr wrap="square" lIns="0" tIns="0" rIns="0" bIns="0" rtlCol="0" anchor="ctr"/>
           <a:lstStyle/>
           <a:p>
-            <a:pPr marL="0" indent="0">
+            <a:pPr indent="0" marL="0">
               <a:buNone/>
             </a:pPr>
             <a:r>
@@ -3137,7 +3466,7 @@
           <a:bodyPr wrap="square" lIns="0" tIns="0" rIns="0" bIns="0" rtlCol="0" anchor="ctr"/>
           <a:lstStyle/>
           <a:p>
-            <a:pPr marL="0" indent="0">
+            <a:pPr indent="0" marL="0">
               <a:buNone/>
             </a:pPr>
             <a:r>
@@ -3177,13 +3506,6 @@
             <a:prstDash val="solid"/>
           </a:ln>
         </p:spPr>
-        <p:txBody>
-          <a:bodyPr/>
-          <a:lstStyle/>
-          <a:p>
-            <a:endParaRPr lang="ko-KR" altLang="en-US"/>
-          </a:p>
-        </p:txBody>
       </p:sp>
       <p:sp>
         <p:nvSpPr>
@@ -3206,7 +3528,7 @@
           <a:bodyPr wrap="square" lIns="0" tIns="0" rIns="0" bIns="0" rtlCol="0" anchor="ctr"/>
           <a:lstStyle/>
           <a:p>
-            <a:pPr marL="0" indent="0">
+            <a:pPr indent="0" marL="0">
               <a:buNone/>
             </a:pPr>
             <a:r>
@@ -3240,7 +3562,6 @@
         <a:solidFill>
           <a:srgbClr val="FFFFFF"/>
         </a:solidFill>
-        <a:effectLst/>
       </p:bgPr>
     </p:bg>
     <p:spTree>
@@ -3278,11 +3599,11 @@
           <a:bodyPr wrap="square" lIns="0" tIns="0" rIns="0" bIns="0" rtlCol="0" anchor="ctr"/>
           <a:lstStyle/>
           <a:p>
-            <a:pPr marL="0" indent="0">
+            <a:pPr indent="0" marL="0">
               <a:buNone/>
             </a:pPr>
             <a:r>
-              <a:rPr lang="en-US" sz="1100" b="1" kern="0" spc="300" dirty="0">
+              <a:rPr lang="en-US" sz="1100" b="1" spc="300" kern="0" dirty="0">
                 <a:solidFill>
                   <a:srgbClr val="0E7C86"/>
                 </a:solidFill>
@@ -3317,7 +3638,7 @@
           <a:bodyPr wrap="square" lIns="0" tIns="0" rIns="0" bIns="0" rtlCol="0" anchor="t"/>
           <a:lstStyle/>
           <a:p>
-            <a:pPr marL="0" indent="0">
+            <a:pPr indent="0" marL="0">
               <a:buNone/>
             </a:pPr>
             <a:r>
@@ -3351,55 +3672,19 @@
         </p:nvGraphicFramePr>
         <p:xfrm>
           <a:off x="731520" y="2240280"/>
-          <a:ext cx="10698480" cy="2834640"/>
+          <a:ext cx="10698480" cy="2651760"/>
         </p:xfrm>
         <a:graphic>
           <a:graphicData uri="http://schemas.openxmlformats.org/drawingml/2006/table">
             <a:tbl>
               <a:tblPr/>
               <a:tblGrid>
-                <a:gridCol w="1828800">
-                  <a:extLst>
-                    <a:ext uri="{9D8B030D-6E8A-4147-A177-3AD203B41FA5}">
-                      <a16:colId xmlns:a16="http://schemas.microsoft.com/office/drawing/2014/main" val="20000"/>
-                    </a:ext>
-                  </a:extLst>
-                </a:gridCol>
-                <a:gridCol w="1188720">
-                  <a:extLst>
-                    <a:ext uri="{9D8B030D-6E8A-4147-A177-3AD203B41FA5}">
-                      <a16:colId xmlns:a16="http://schemas.microsoft.com/office/drawing/2014/main" val="20001"/>
-                    </a:ext>
-                  </a:extLst>
-                </a:gridCol>
-                <a:gridCol w="1920240">
-                  <a:extLst>
-                    <a:ext uri="{9D8B030D-6E8A-4147-A177-3AD203B41FA5}">
-                      <a16:colId xmlns:a16="http://schemas.microsoft.com/office/drawing/2014/main" val="20002"/>
-                    </a:ext>
-                  </a:extLst>
-                </a:gridCol>
-                <a:gridCol w="1920240">
-                  <a:extLst>
-                    <a:ext uri="{9D8B030D-6E8A-4147-A177-3AD203B41FA5}">
-                      <a16:colId xmlns:a16="http://schemas.microsoft.com/office/drawing/2014/main" val="20003"/>
-                    </a:ext>
-                  </a:extLst>
-                </a:gridCol>
-                <a:gridCol w="1920240">
-                  <a:extLst>
-                    <a:ext uri="{9D8B030D-6E8A-4147-A177-3AD203B41FA5}">
-                      <a16:colId xmlns:a16="http://schemas.microsoft.com/office/drawing/2014/main" val="20004"/>
-                    </a:ext>
-                  </a:extLst>
-                </a:gridCol>
-                <a:gridCol w="1920240">
-                  <a:extLst>
-                    <a:ext uri="{9D8B030D-6E8A-4147-A177-3AD203B41FA5}">
-                      <a16:colId xmlns:a16="http://schemas.microsoft.com/office/drawing/2014/main" val="20005"/>
-                    </a:ext>
-                  </a:extLst>
-                </a:gridCol>
+                <a:gridCol w="1828800"/>
+                <a:gridCol w="1188720"/>
+                <a:gridCol w="1920240"/>
+                <a:gridCol w="1920240"/>
+                <a:gridCol w="1920240"/>
+                <a:gridCol w="1920240"/>
               </a:tblGrid>
               <a:tr h="566928">
                 <a:tc>
@@ -3407,7 +3692,7 @@
                     <a:bodyPr/>
                     <a:lstStyle/>
                     <a:p>
-                      <a:pPr marL="0" indent="0" algn="ctr">
+                      <a:pPr algn="ctr" indent="0" marL="0">
                         <a:buNone/>
                       </a:pPr>
                       <a:r>
@@ -3419,7 +3704,7 @@
                           <a:ea typeface="Calibri" pitchFamily="34" charset="-122"/>
                           <a:cs typeface="Calibri" pitchFamily="34" charset="-120"/>
                         </a:rPr>
-                        <a:t>V</a:t>
+                        <a:t>V·Δt</a:t>
                       </a:r>
                       <a:endParaRPr lang="en-US" sz="1250" dirty="0">
                         <a:latin typeface="Calibri" charset="0"/>
@@ -3428,7 +3713,7 @@
                       </a:endParaRPr>
                     </a:p>
                   </a:txBody>
-                  <a:tcPr anchor="ctr">
+                  <a:tcPr marL="91440" marR="91440" marT="45720" marB="45720" anchor="ctr">
                     <a:lnL w="6350" cap="flat" cmpd="sng" algn="ctr">
                       <a:solidFill>
                         <a:srgbClr val="CBD2D9"/>
@@ -3475,7 +3760,7 @@
                     <a:bodyPr/>
                     <a:lstStyle/>
                     <a:p>
-                      <a:pPr marL="0" indent="0" algn="ctr">
+                      <a:pPr algn="ctr" indent="0" marL="0">
                         <a:buNone/>
                       </a:pPr>
                       <a:r>
@@ -3496,7 +3781,7 @@
                       </a:endParaRPr>
                     </a:p>
                   </a:txBody>
-                  <a:tcPr anchor="ctr">
+                  <a:tcPr marL="91440" marR="91440" marT="45720" marB="45720" anchor="ctr">
                     <a:lnL w="6350" cap="flat" cmpd="sng" algn="ctr">
                       <a:solidFill>
                         <a:srgbClr val="CBD2D9"/>
@@ -3543,7 +3828,7 @@
                     <a:bodyPr/>
                     <a:lstStyle/>
                     <a:p>
-                      <a:pPr marL="0" indent="0" algn="ctr">
+                      <a:pPr algn="ctr" indent="0" marL="0">
                         <a:buNone/>
                       </a:pPr>
                       <a:r>
@@ -3564,7 +3849,7 @@
                       </a:endParaRPr>
                     </a:p>
                   </a:txBody>
-                  <a:tcPr anchor="ctr">
+                  <a:tcPr marL="91440" marR="91440" marT="45720" marB="45720" anchor="ctr">
                     <a:lnL w="6350" cap="flat" cmpd="sng" algn="ctr">
                       <a:solidFill>
                         <a:srgbClr val="CBD2D9"/>
@@ -3611,7 +3896,7 @@
                     <a:bodyPr/>
                     <a:lstStyle/>
                     <a:p>
-                      <a:pPr marL="0" indent="0" algn="ctr">
+                      <a:pPr algn="ctr" indent="0" marL="0">
                         <a:buNone/>
                       </a:pPr>
                       <a:r>
@@ -3632,7 +3917,7 @@
                       </a:endParaRPr>
                     </a:p>
                   </a:txBody>
-                  <a:tcPr anchor="ctr">
+                  <a:tcPr marL="91440" marR="91440" marT="45720" marB="45720" anchor="ctr">
                     <a:lnL w="6350" cap="flat" cmpd="sng" algn="ctr">
                       <a:solidFill>
                         <a:srgbClr val="CBD2D9"/>
@@ -3679,7 +3964,7 @@
                     <a:bodyPr/>
                     <a:lstStyle/>
                     <a:p>
-                      <a:pPr marL="0" indent="0" algn="ctr">
+                      <a:pPr algn="ctr" indent="0" marL="0">
                         <a:buNone/>
                       </a:pPr>
                       <a:r>
@@ -3700,7 +3985,7 @@
                       </a:endParaRPr>
                     </a:p>
                   </a:txBody>
-                  <a:tcPr anchor="ctr">
+                  <a:tcPr marL="91440" marR="91440" marT="45720" marB="45720" anchor="ctr">
                     <a:lnL w="6350" cap="flat" cmpd="sng" algn="ctr">
                       <a:solidFill>
                         <a:srgbClr val="CBD2D9"/>
@@ -3747,7 +4032,7 @@
                     <a:bodyPr/>
                     <a:lstStyle/>
                     <a:p>
-                      <a:pPr marL="0" indent="0" algn="ctr">
+                      <a:pPr algn="ctr" indent="0" marL="0">
                         <a:buNone/>
                       </a:pPr>
                       <a:r>
@@ -3768,7 +4053,7 @@
                       </a:endParaRPr>
                     </a:p>
                   </a:txBody>
-                  <a:tcPr anchor="ctr">
+                  <a:tcPr marL="91440" marR="91440" marT="45720" marB="45720" anchor="ctr">
                     <a:lnL w="6350" cap="flat" cmpd="sng" algn="ctr">
                       <a:solidFill>
                         <a:srgbClr val="CBD2D9"/>
@@ -3810,11 +4095,6 @@
                     </a:solidFill>
                   </a:tcPr>
                 </a:tc>
-                <a:extLst>
-                  <a:ext uri="{0D108BD9-81ED-4DB2-BD59-A6C34878D82A}">
-                    <a16:rowId xmlns:a16="http://schemas.microsoft.com/office/drawing/2014/main" val="10000"/>
-                  </a:ext>
-                </a:extLst>
               </a:tr>
               <a:tr h="566928">
                 <a:tc>
@@ -3822,7 +4102,7 @@
                     <a:bodyPr/>
                     <a:lstStyle/>
                     <a:p>
-                      <a:pPr marL="0" indent="0" algn="ctr">
+                      <a:pPr algn="ctr" indent="0" marL="0">
                         <a:buNone/>
                       </a:pPr>
                       <a:r>
@@ -3843,7 +4123,7 @@
                       </a:endParaRPr>
                     </a:p>
                   </a:txBody>
-                  <a:tcPr anchor="ctr">
+                  <a:tcPr marL="91440" marR="91440" marT="45720" marB="45720" anchor="ctr">
                     <a:lnL w="6350" cap="flat" cmpd="sng" algn="ctr">
                       <a:solidFill>
                         <a:srgbClr val="CBD2D9"/>
@@ -3887,7 +4167,7 @@
                     <a:bodyPr/>
                     <a:lstStyle/>
                     <a:p>
-                      <a:pPr marL="0" indent="0" algn="ctr">
+                      <a:pPr algn="ctr" indent="0" marL="0">
                         <a:buNone/>
                       </a:pPr>
                       <a:r>
@@ -3908,7 +4188,7 @@
                       </a:endParaRPr>
                     </a:p>
                   </a:txBody>
-                  <a:tcPr anchor="ctr">
+                  <a:tcPr marL="91440" marR="91440" marT="45720" marB="45720" anchor="ctr">
                     <a:lnL w="6350" cap="flat" cmpd="sng" algn="ctr">
                       <a:solidFill>
                         <a:srgbClr val="CBD2D9"/>
@@ -3952,7 +4232,7 @@
                     <a:bodyPr/>
                     <a:lstStyle/>
                     <a:p>
-                      <a:pPr marL="0" indent="0" algn="ctr">
+                      <a:pPr algn="ctr" indent="0" marL="0">
                         <a:buNone/>
                       </a:pPr>
                       <a:r>
@@ -3973,7 +4253,7 @@
                       </a:endParaRPr>
                     </a:p>
                   </a:txBody>
-                  <a:tcPr anchor="ctr">
+                  <a:tcPr marL="91440" marR="91440" marT="45720" marB="45720" anchor="ctr">
                     <a:lnL w="6350" cap="flat" cmpd="sng" algn="ctr">
                       <a:solidFill>
                         <a:srgbClr val="CBD2D9"/>
@@ -4017,7 +4297,7 @@
                     <a:bodyPr/>
                     <a:lstStyle/>
                     <a:p>
-                      <a:pPr marL="0" indent="0" algn="ctr">
+                      <a:pPr algn="ctr" indent="0" marL="0">
                         <a:buNone/>
                       </a:pPr>
                       <a:r>
@@ -4038,7 +4318,7 @@
                       </a:endParaRPr>
                     </a:p>
                   </a:txBody>
-                  <a:tcPr anchor="ctr">
+                  <a:tcPr marL="91440" marR="91440" marT="45720" marB="45720" anchor="ctr">
                     <a:lnL w="6350" cap="flat" cmpd="sng" algn="ctr">
                       <a:solidFill>
                         <a:srgbClr val="CBD2D9"/>
@@ -4082,7 +4362,7 @@
                     <a:bodyPr/>
                     <a:lstStyle/>
                     <a:p>
-                      <a:pPr marL="0" indent="0" algn="ctr">
+                      <a:pPr algn="ctr" indent="0" marL="0">
                         <a:buNone/>
                       </a:pPr>
                       <a:r>
@@ -4103,7 +4383,7 @@
                       </a:endParaRPr>
                     </a:p>
                   </a:txBody>
-                  <a:tcPr anchor="ctr">
+                  <a:tcPr marL="91440" marR="91440" marT="45720" marB="45720" anchor="ctr">
                     <a:lnL w="6350" cap="flat" cmpd="sng" algn="ctr">
                       <a:solidFill>
                         <a:srgbClr val="CBD2D9"/>
@@ -4147,7 +4427,7 @@
                     <a:bodyPr/>
                     <a:lstStyle/>
                     <a:p>
-                      <a:pPr marL="0" indent="0" algn="ctr">
+                      <a:pPr algn="ctr" indent="0" marL="0">
                         <a:buNone/>
                       </a:pPr>
                       <a:r>
@@ -4168,7 +4448,7 @@
                       </a:endParaRPr>
                     </a:p>
                   </a:txBody>
-                  <a:tcPr anchor="ctr">
+                  <a:tcPr marL="91440" marR="91440" marT="45720" marB="45720" anchor="ctr">
                     <a:lnL w="6350" cap="flat" cmpd="sng" algn="ctr">
                       <a:solidFill>
                         <a:srgbClr val="CBD2D9"/>
@@ -4207,11 +4487,6 @@
                     </a:lnB>
                   </a:tcPr>
                 </a:tc>
-                <a:extLst>
-                  <a:ext uri="{0D108BD9-81ED-4DB2-BD59-A6C34878D82A}">
-                    <a16:rowId xmlns:a16="http://schemas.microsoft.com/office/drawing/2014/main" val="10001"/>
-                  </a:ext>
-                </a:extLst>
               </a:tr>
               <a:tr h="566928">
                 <a:tc>
@@ -4219,7 +4494,7 @@
                     <a:bodyPr/>
                     <a:lstStyle/>
                     <a:p>
-                      <a:pPr marL="0" indent="0" algn="ctr">
+                      <a:pPr algn="ctr" indent="0" marL="0">
                         <a:buNone/>
                       </a:pPr>
                       <a:r>
@@ -4240,7 +4515,7 @@
                       </a:endParaRPr>
                     </a:p>
                   </a:txBody>
-                  <a:tcPr anchor="ctr">
+                  <a:tcPr marL="91440" marR="91440" marT="45720" marB="45720" anchor="ctr">
                     <a:lnL w="6350" cap="flat" cmpd="sng" algn="ctr">
                       <a:solidFill>
                         <a:srgbClr val="CBD2D9"/>
@@ -4284,7 +4559,7 @@
                     <a:bodyPr/>
                     <a:lstStyle/>
                     <a:p>
-                      <a:pPr marL="0" indent="0" algn="ctr">
+                      <a:pPr algn="ctr" indent="0" marL="0">
                         <a:buNone/>
                       </a:pPr>
                       <a:r>
@@ -4305,7 +4580,7 @@
                       </a:endParaRPr>
                     </a:p>
                   </a:txBody>
-                  <a:tcPr anchor="ctr">
+                  <a:tcPr marL="91440" marR="91440" marT="45720" marB="45720" anchor="ctr">
                     <a:lnL w="6350" cap="flat" cmpd="sng" algn="ctr">
                       <a:solidFill>
                         <a:srgbClr val="CBD2D9"/>
@@ -4349,7 +4624,7 @@
                     <a:bodyPr/>
                     <a:lstStyle/>
                     <a:p>
-                      <a:pPr marL="0" indent="0" algn="ctr">
+                      <a:pPr algn="ctr" indent="0" marL="0">
                         <a:buNone/>
                       </a:pPr>
                       <a:r>
@@ -4370,7 +4645,7 @@
                       </a:endParaRPr>
                     </a:p>
                   </a:txBody>
-                  <a:tcPr anchor="ctr">
+                  <a:tcPr marL="91440" marR="91440" marT="45720" marB="45720" anchor="ctr">
                     <a:lnL w="6350" cap="flat" cmpd="sng" algn="ctr">
                       <a:solidFill>
                         <a:srgbClr val="CBD2D9"/>
@@ -4414,7 +4689,7 @@
                     <a:bodyPr/>
                     <a:lstStyle/>
                     <a:p>
-                      <a:pPr marL="0" indent="0" algn="ctr">
+                      <a:pPr algn="ctr" indent="0" marL="0">
                         <a:buNone/>
                       </a:pPr>
                       <a:r>
@@ -4435,7 +4710,7 @@
                       </a:endParaRPr>
                     </a:p>
                   </a:txBody>
-                  <a:tcPr anchor="ctr">
+                  <a:tcPr marL="91440" marR="91440" marT="45720" marB="45720" anchor="ctr">
                     <a:lnL w="6350" cap="flat" cmpd="sng" algn="ctr">
                       <a:solidFill>
                         <a:srgbClr val="CBD2D9"/>
@@ -4479,7 +4754,7 @@
                     <a:bodyPr/>
                     <a:lstStyle/>
                     <a:p>
-                      <a:pPr marL="0" indent="0" algn="ctr">
+                      <a:pPr algn="ctr" indent="0" marL="0">
                         <a:buNone/>
                       </a:pPr>
                       <a:r>
@@ -4500,7 +4775,7 @@
                       </a:endParaRPr>
                     </a:p>
                   </a:txBody>
-                  <a:tcPr anchor="ctr">
+                  <a:tcPr marL="91440" marR="91440" marT="45720" marB="45720" anchor="ctr">
                     <a:lnL w="6350" cap="flat" cmpd="sng" algn="ctr">
                       <a:solidFill>
                         <a:srgbClr val="CBD2D9"/>
@@ -4544,7 +4819,7 @@
                     <a:bodyPr/>
                     <a:lstStyle/>
                     <a:p>
-                      <a:pPr marL="0" indent="0" algn="ctr">
+                      <a:pPr algn="ctr" indent="0" marL="0">
                         <a:buNone/>
                       </a:pPr>
                       <a:r>
@@ -4565,7 +4840,7 @@
                       </a:endParaRPr>
                     </a:p>
                   </a:txBody>
-                  <a:tcPr anchor="ctr">
+                  <a:tcPr marL="91440" marR="91440" marT="45720" marB="45720" anchor="ctr">
                     <a:lnL w="6350" cap="flat" cmpd="sng" algn="ctr">
                       <a:solidFill>
                         <a:srgbClr val="CBD2D9"/>
@@ -4604,11 +4879,6 @@
                     </a:lnB>
                   </a:tcPr>
                 </a:tc>
-                <a:extLst>
-                  <a:ext uri="{0D108BD9-81ED-4DB2-BD59-A6C34878D82A}">
-                    <a16:rowId xmlns:a16="http://schemas.microsoft.com/office/drawing/2014/main" val="10002"/>
-                  </a:ext>
-                </a:extLst>
               </a:tr>
               <a:tr h="566928">
                 <a:tc>
@@ -4616,7 +4886,7 @@
                     <a:bodyPr/>
                     <a:lstStyle/>
                     <a:p>
-                      <a:pPr marL="0" indent="0" algn="ctr">
+                      <a:pPr algn="ctr" indent="0" marL="0">
                         <a:buNone/>
                       </a:pPr>
                       <a:r>
@@ -4637,7 +4907,7 @@
                       </a:endParaRPr>
                     </a:p>
                   </a:txBody>
-                  <a:tcPr anchor="ctr">
+                  <a:tcPr marL="91440" marR="91440" marT="45720" marB="45720" anchor="ctr">
                     <a:lnL w="6350" cap="flat" cmpd="sng" algn="ctr">
                       <a:solidFill>
                         <a:srgbClr val="CBD2D9"/>
@@ -4681,7 +4951,7 @@
                     <a:bodyPr/>
                     <a:lstStyle/>
                     <a:p>
-                      <a:pPr marL="0" indent="0" algn="ctr">
+                      <a:pPr algn="ctr" indent="0" marL="0">
                         <a:buNone/>
                       </a:pPr>
                       <a:r>
@@ -4702,7 +4972,7 @@
                       </a:endParaRPr>
                     </a:p>
                   </a:txBody>
-                  <a:tcPr anchor="ctr">
+                  <a:tcPr marL="91440" marR="91440" marT="45720" marB="45720" anchor="ctr">
                     <a:lnL w="6350" cap="flat" cmpd="sng" algn="ctr">
                       <a:solidFill>
                         <a:srgbClr val="CBD2D9"/>
@@ -4746,7 +5016,7 @@
                     <a:bodyPr/>
                     <a:lstStyle/>
                     <a:p>
-                      <a:pPr marL="0" indent="0" algn="ctr">
+                      <a:pPr algn="ctr" indent="0" marL="0">
                         <a:buNone/>
                       </a:pPr>
                       <a:r>
@@ -4767,7 +5037,7 @@
                       </a:endParaRPr>
                     </a:p>
                   </a:txBody>
-                  <a:tcPr anchor="ctr">
+                  <a:tcPr marL="91440" marR="91440" marT="45720" marB="45720" anchor="ctr">
                     <a:lnL w="6350" cap="flat" cmpd="sng" algn="ctr">
                       <a:solidFill>
                         <a:srgbClr val="CBD2D9"/>
@@ -4811,7 +5081,7 @@
                     <a:bodyPr/>
                     <a:lstStyle/>
                     <a:p>
-                      <a:pPr marL="0" indent="0" algn="ctr">
+                      <a:pPr algn="ctr" indent="0" marL="0">
                         <a:buNone/>
                       </a:pPr>
                       <a:r>
@@ -4832,7 +5102,7 @@
                       </a:endParaRPr>
                     </a:p>
                   </a:txBody>
-                  <a:tcPr anchor="ctr">
+                  <a:tcPr marL="91440" marR="91440" marT="45720" marB="45720" anchor="ctr">
                     <a:lnL w="6350" cap="flat" cmpd="sng" algn="ctr">
                       <a:solidFill>
                         <a:srgbClr val="CBD2D9"/>
@@ -4876,7 +5146,7 @@
                     <a:bodyPr/>
                     <a:lstStyle/>
                     <a:p>
-                      <a:pPr marL="0" indent="0" algn="ctr">
+                      <a:pPr algn="ctr" indent="0" marL="0">
                         <a:buNone/>
                       </a:pPr>
                       <a:r>
@@ -4897,7 +5167,7 @@
                       </a:endParaRPr>
                     </a:p>
                   </a:txBody>
-                  <a:tcPr anchor="ctr">
+                  <a:tcPr marL="91440" marR="91440" marT="45720" marB="45720" anchor="ctr">
                     <a:lnL w="6350" cap="flat" cmpd="sng" algn="ctr">
                       <a:solidFill>
                         <a:srgbClr val="CBD2D9"/>
@@ -4941,7 +5211,7 @@
                     <a:bodyPr/>
                     <a:lstStyle/>
                     <a:p>
-                      <a:pPr marL="0" indent="0" algn="ctr">
+                      <a:pPr algn="ctr" indent="0" marL="0">
                         <a:buNone/>
                       </a:pPr>
                       <a:r>
@@ -4962,7 +5232,7 @@
                       </a:endParaRPr>
                     </a:p>
                   </a:txBody>
-                  <a:tcPr anchor="ctr">
+                  <a:tcPr marL="91440" marR="91440" marT="45720" marB="45720" anchor="ctr">
                     <a:lnL w="6350" cap="flat" cmpd="sng" algn="ctr">
                       <a:solidFill>
                         <a:srgbClr val="CBD2D9"/>
@@ -5001,11 +5271,6 @@
                     </a:lnB>
                   </a:tcPr>
                 </a:tc>
-                <a:extLst>
-                  <a:ext uri="{0D108BD9-81ED-4DB2-BD59-A6C34878D82A}">
-                    <a16:rowId xmlns:a16="http://schemas.microsoft.com/office/drawing/2014/main" val="10003"/>
-                  </a:ext>
-                </a:extLst>
               </a:tr>
               <a:tr h="566928">
                 <a:tc>
@@ -5013,7 +5278,7 @@
                     <a:bodyPr/>
                     <a:lstStyle/>
                     <a:p>
-                      <a:pPr marL="0" indent="0" algn="ctr">
+                      <a:pPr algn="ctr" indent="0" marL="0">
                         <a:buNone/>
                       </a:pPr>
                       <a:r>
@@ -5034,7 +5299,7 @@
                       </a:endParaRPr>
                     </a:p>
                   </a:txBody>
-                  <a:tcPr anchor="ctr">
+                  <a:tcPr marL="91440" marR="91440" marT="45720" marB="45720" anchor="ctr">
                     <a:lnL w="6350" cap="flat" cmpd="sng" algn="ctr">
                       <a:solidFill>
                         <a:srgbClr val="CBD2D9"/>
@@ -5078,7 +5343,7 @@
                     <a:bodyPr/>
                     <a:lstStyle/>
                     <a:p>
-                      <a:pPr marL="0" indent="0" algn="ctr">
+                      <a:pPr algn="ctr" indent="0" marL="0">
                         <a:buNone/>
                       </a:pPr>
                       <a:r>
@@ -5099,7 +5364,7 @@
                       </a:endParaRPr>
                     </a:p>
                   </a:txBody>
-                  <a:tcPr anchor="ctr">
+                  <a:tcPr marL="91440" marR="91440" marT="45720" marB="45720" anchor="ctr">
                     <a:lnL w="6350" cap="flat" cmpd="sng" algn="ctr">
                       <a:solidFill>
                         <a:srgbClr val="CBD2D9"/>
@@ -5143,7 +5408,7 @@
                     <a:bodyPr/>
                     <a:lstStyle/>
                     <a:p>
-                      <a:pPr marL="0" indent="0" algn="ctr">
+                      <a:pPr algn="ctr" indent="0" marL="0">
                         <a:buNone/>
                       </a:pPr>
                       <a:r>
@@ -5164,7 +5429,7 @@
                       </a:endParaRPr>
                     </a:p>
                   </a:txBody>
-                  <a:tcPr anchor="ctr">
+                  <a:tcPr marL="91440" marR="91440" marT="45720" marB="45720" anchor="ctr">
                     <a:lnL w="6350" cap="flat" cmpd="sng" algn="ctr">
                       <a:solidFill>
                         <a:srgbClr val="CBD2D9"/>
@@ -5208,7 +5473,7 @@
                     <a:bodyPr/>
                     <a:lstStyle/>
                     <a:p>
-                      <a:pPr marL="0" indent="0" algn="ctr">
+                      <a:pPr algn="ctr" indent="0" marL="0">
                         <a:buNone/>
                       </a:pPr>
                       <a:r>
@@ -5229,7 +5494,7 @@
                       </a:endParaRPr>
                     </a:p>
                   </a:txBody>
-                  <a:tcPr anchor="ctr">
+                  <a:tcPr marL="91440" marR="91440" marT="45720" marB="45720" anchor="ctr">
                     <a:lnL w="6350" cap="flat" cmpd="sng" algn="ctr">
                       <a:solidFill>
                         <a:srgbClr val="CBD2D9"/>
@@ -5273,7 +5538,7 @@
                     <a:bodyPr/>
                     <a:lstStyle/>
                     <a:p>
-                      <a:pPr marL="0" indent="0" algn="ctr">
+                      <a:pPr algn="ctr" indent="0" marL="0">
                         <a:buNone/>
                       </a:pPr>
                       <a:r>
@@ -5294,7 +5559,7 @@
                       </a:endParaRPr>
                     </a:p>
                   </a:txBody>
-                  <a:tcPr anchor="ctr">
+                  <a:tcPr marL="91440" marR="91440" marT="45720" marB="45720" anchor="ctr">
                     <a:lnL w="6350" cap="flat" cmpd="sng" algn="ctr">
                       <a:solidFill>
                         <a:srgbClr val="CBD2D9"/>
@@ -5338,7 +5603,7 @@
                     <a:bodyPr/>
                     <a:lstStyle/>
                     <a:p>
-                      <a:pPr marL="0" indent="0" algn="ctr">
+                      <a:pPr algn="ctr" indent="0" marL="0">
                         <a:buNone/>
                       </a:pPr>
                       <a:r>
@@ -5359,7 +5624,7 @@
                       </a:endParaRPr>
                     </a:p>
                   </a:txBody>
-                  <a:tcPr anchor="ctr">
+                  <a:tcPr marL="91440" marR="91440" marT="45720" marB="45720" anchor="ctr">
                     <a:lnL w="6350" cap="flat" cmpd="sng" algn="ctr">
                       <a:solidFill>
                         <a:srgbClr val="CBD2D9"/>
@@ -5398,11 +5663,6 @@
                     </a:lnB>
                   </a:tcPr>
                 </a:tc>
-                <a:extLst>
-                  <a:ext uri="{0D108BD9-81ED-4DB2-BD59-A6C34878D82A}">
-                    <a16:rowId xmlns:a16="http://schemas.microsoft.com/office/drawing/2014/main" val="10004"/>
-                  </a:ext>
-                </a:extLst>
               </a:tr>
             </a:tbl>
           </a:graphicData>
@@ -5429,7 +5689,7 @@
           <a:bodyPr wrap="square" lIns="0" tIns="0" rIns="0" bIns="0" rtlCol="0" anchor="ctr"/>
           <a:lstStyle/>
           <a:p>
-            <a:pPr marL="0" indent="0">
+            <a:pPr indent="0" marL="0">
               <a:buNone/>
             </a:pPr>
             <a:r>
@@ -5443,6 +5703,9 @@
               </a:rPr>
               <a:t>PATH error is the real metric</a:t>
             </a:r>
+            <a:pPr indent="0" marL="0">
+              <a:buNone/>
+            </a:pPr>
             <a:r>
               <a:rPr lang="en-US" sz="1300" dirty="0">
                 <a:solidFill>
@@ -5479,7 +5742,7 @@
           <a:bodyPr wrap="square" lIns="0" tIns="0" rIns="0" bIns="0" rtlCol="0" anchor="ctr"/>
           <a:lstStyle/>
           <a:p>
-            <a:pPr marL="0" indent="0">
+            <a:pPr indent="0" marL="0">
               <a:buNone/>
             </a:pPr>
             <a:r>
@@ -5491,7 +5754,7 @@
                 <a:ea typeface="Calibri" pitchFamily="34" charset="-122"/>
                 <a:cs typeface="Calibri" pitchFamily="34" charset="-120"/>
               </a:rPr>
-              <a:t>Smaller V → finer steps → a bigger graph, but more accurate.  Chosen V=500: max w = H = 28, path error 3.6%.</a:t>
+              <a:t>Smaller V·Δt → finer steps → a bigger graph, but more accurate.  Chosen V·Δt=500: max w = 28, path error 3.6%.</a:t>
             </a:r>
             <a:endParaRPr lang="en-US" sz="1300" dirty="0"/>
           </a:p>
@@ -5513,7 +5776,6 @@
         <a:solidFill>
           <a:srgbClr val="FFFFFF"/>
         </a:solidFill>
-        <a:effectLst/>
       </p:bgPr>
     </p:bg>
     <p:spTree>
@@ -5551,11 +5813,11 @@
           <a:bodyPr wrap="square" lIns="0" tIns="0" rIns="0" bIns="0" rtlCol="0" anchor="ctr"/>
           <a:lstStyle/>
           <a:p>
-            <a:pPr marL="0" indent="0">
+            <a:pPr indent="0" marL="0">
               <a:buNone/>
             </a:pPr>
             <a:r>
-              <a:rPr lang="en-US" sz="1100" b="1" kern="0" spc="300" dirty="0">
+              <a:rPr lang="en-US" sz="1100" b="1" spc="300" kern="0" dirty="0">
                 <a:solidFill>
                   <a:srgbClr val="0E7C86"/>
                 </a:solidFill>
@@ -5590,7 +5852,7 @@
           <a:bodyPr wrap="square" lIns="0" tIns="0" rIns="0" bIns="0" rtlCol="0" anchor="t"/>
           <a:lstStyle/>
           <a:p>
-            <a:pPr marL="0" indent="0">
+            <a:pPr indent="0" marL="0">
               <a:buNone/>
             </a:pPr>
             <a:r>
@@ -5629,7 +5891,7 @@
           <a:bodyPr wrap="square" lIns="0" tIns="0" rIns="0" bIns="0" rtlCol="0" anchor="t"/>
           <a:lstStyle/>
           <a:p>
-            <a:pPr marL="0" indent="0">
+            <a:pPr indent="0" marL="0">
               <a:buNone/>
             </a:pPr>
             <a:r>
@@ -5649,14 +5911,14 @@
       </p:sp>
       <p:pic>
         <p:nvPicPr>
-          <p:cNvPr id="5" name="Image 0" descr="/sessions/youthful-relaxed-maxwell/mnt/OHT_MAPF/results/assets/fig_pp.png"/>
+          <p:cNvPr id="5" name="Image 0" descr="/sessions/youthful-relaxed-maxwell/mnt/OHT_MAPF/results/assets/fig_pp.png">    </p:cNvPr>
           <p:cNvPicPr>
             <a:picLocks noChangeAspect="1"/>
           </p:cNvPicPr>
           <p:nvPr/>
         </p:nvPicPr>
         <p:blipFill>
-          <a:blip r:embed="rId3"/>
+          <a:blip r:embed="rId1"/>
           <a:stretch>
             <a:fillRect/>
           </a:stretch>
@@ -5687,7 +5949,6 @@
         <a:solidFill>
           <a:srgbClr val="FFFFFF"/>
         </a:solidFill>
-        <a:effectLst/>
       </p:bgPr>
     </p:bg>
     <p:spTree>
@@ -5725,11 +5986,11 @@
           <a:bodyPr wrap="square" lIns="0" tIns="0" rIns="0" bIns="0" rtlCol="0" anchor="ctr"/>
           <a:lstStyle/>
           <a:p>
-            <a:pPr marL="0" indent="0">
+            <a:pPr indent="0" marL="0">
               <a:buNone/>
             </a:pPr>
             <a:r>
-              <a:rPr lang="en-US" sz="1100" b="1" kern="0" spc="300" dirty="0">
+              <a:rPr lang="en-US" sz="1100" b="1" spc="300" kern="0" dirty="0">
                 <a:solidFill>
                   <a:srgbClr val="0E7C86"/>
                 </a:solidFill>
@@ -5764,7 +6025,7 @@
           <a:bodyPr wrap="square" lIns="0" tIns="0" rIns="0" bIns="0" rtlCol="0" anchor="t"/>
           <a:lstStyle/>
           <a:p>
-            <a:pPr marL="0" indent="0">
+            <a:pPr indent="0" marL="0">
               <a:buNone/>
             </a:pPr>
             <a:r>
@@ -5803,7 +6064,7 @@
           <a:bodyPr wrap="square" lIns="0" tIns="0" rIns="0" bIns="0" rtlCol="0" anchor="t"/>
           <a:lstStyle/>
           <a:p>
-            <a:pPr marL="0" indent="0">
+            <a:pPr indent="0" marL="0">
               <a:buNone/>
             </a:pPr>
             <a:r>
@@ -5823,14 +6084,14 @@
       </p:sp>
       <p:pic>
         <p:nvPicPr>
-          <p:cNvPr id="5" name="Image 0" descr="/sessions/youthful-relaxed-maxwell/mnt/OHT_MAPF/results/assets/fig_roles.png"/>
+          <p:cNvPr id="5" name="Image 0" descr="/sessions/youthful-relaxed-maxwell/mnt/OHT_MAPF/results/assets/fig_roles.png">    </p:cNvPr>
           <p:cNvPicPr>
             <a:picLocks noChangeAspect="1"/>
           </p:cNvPicPr>
           <p:nvPr/>
         </p:nvPicPr>
         <p:blipFill>
-          <a:blip r:embed="rId3"/>
+          <a:blip r:embed="rId1"/>
           <a:stretch>
             <a:fillRect/>
           </a:stretch>
@@ -5861,7 +6122,6 @@
         <a:solidFill>
           <a:srgbClr val="FFFFFF"/>
         </a:solidFill>
-        <a:effectLst/>
       </p:bgPr>
     </p:bg>
     <p:spTree>
@@ -5899,11 +6159,11 @@
           <a:bodyPr wrap="square" lIns="0" tIns="0" rIns="0" bIns="0" rtlCol="0" anchor="ctr"/>
           <a:lstStyle/>
           <a:p>
-            <a:pPr marL="0" indent="0">
+            <a:pPr indent="0" marL="0">
               <a:buNone/>
             </a:pPr>
             <a:r>
-              <a:rPr lang="en-US" sz="1100" b="1" kern="0" spc="300" dirty="0">
+              <a:rPr lang="en-US" sz="1100" b="1" spc="300" kern="0" dirty="0">
                 <a:solidFill>
                   <a:srgbClr val="0E7C86"/>
                 </a:solidFill>
@@ -5938,7 +6198,7 @@
           <a:bodyPr wrap="square" lIns="0" tIns="0" rIns="0" bIns="0" rtlCol="0" anchor="t"/>
           <a:lstStyle/>
           <a:p>
-            <a:pPr marL="0" indent="0">
+            <a:pPr indent="0" marL="0">
               <a:buNone/>
             </a:pPr>
             <a:r>
@@ -5977,7 +6237,7 @@
           <a:bodyPr wrap="square" lIns="0" tIns="0" rIns="0" bIns="0" rtlCol="0" anchor="t"/>
           <a:lstStyle/>
           <a:p>
-            <a:pPr marL="0" indent="0">
+            <a:pPr indent="0" marL="0">
               <a:buNone/>
             </a:pPr>
             <a:r>
@@ -5997,14 +6257,14 @@
       </p:sp>
       <p:pic>
         <p:nvPicPr>
-          <p:cNvPr id="5" name="Image 0" descr="/sessions/youthful-relaxed-maxwell/mnt/OHT_MAPF/results/assets/fig_teg.png"/>
+          <p:cNvPr id="5" name="Image 0" descr="/sessions/youthful-relaxed-maxwell/mnt/OHT_MAPF/results/assets/fig_teg.png">    </p:cNvPr>
           <p:cNvPicPr>
             <a:picLocks noChangeAspect="1"/>
           </p:cNvPicPr>
           <p:nvPr/>
         </p:nvPicPr>
         <p:blipFill>
-          <a:blip r:embed="rId3"/>
+          <a:blip r:embed="rId1"/>
           <a:stretch>
             <a:fillRect/>
           </a:stretch>
@@ -6035,7 +6295,6 @@
         <a:solidFill>
           <a:srgbClr val="FFFFFF"/>
         </a:solidFill>
-        <a:effectLst/>
       </p:bgPr>
     </p:bg>
     <p:spTree>
@@ -6073,11 +6332,11 @@
           <a:bodyPr wrap="square" lIns="0" tIns="0" rIns="0" bIns="0" rtlCol="0" anchor="ctr"/>
           <a:lstStyle/>
           <a:p>
-            <a:pPr marL="0" indent="0">
+            <a:pPr indent="0" marL="0">
               <a:buNone/>
             </a:pPr>
             <a:r>
-              <a:rPr lang="en-US" sz="1100" b="1" kern="0" spc="300" dirty="0">
+              <a:rPr lang="en-US" sz="1100" b="1" spc="300" kern="0" dirty="0">
                 <a:solidFill>
                   <a:srgbClr val="0E7C86"/>
                 </a:solidFill>
@@ -6112,7 +6371,7 @@
           <a:bodyPr wrap="square" lIns="0" tIns="0" rIns="0" bIns="0" rtlCol="0" anchor="t"/>
           <a:lstStyle/>
           <a:p>
-            <a:pPr marL="0" indent="0">
+            <a:pPr indent="0" marL="0">
               <a:buNone/>
             </a:pPr>
             <a:r>
@@ -6146,27 +6405,15 @@
         </p:nvGraphicFramePr>
         <p:xfrm>
           <a:off x="1463040" y="2468880"/>
-          <a:ext cx="9235440" cy="2834640"/>
+          <a:ext cx="9235440" cy="2651760"/>
         </p:xfrm>
         <a:graphic>
           <a:graphicData uri="http://schemas.openxmlformats.org/drawingml/2006/table">
             <a:tbl>
               <a:tblPr/>
               <a:tblGrid>
-                <a:gridCol w="3108960">
-                  <a:extLst>
-                    <a:ext uri="{9D8B030D-6E8A-4147-A177-3AD203B41FA5}">
-                      <a16:colId xmlns:a16="http://schemas.microsoft.com/office/drawing/2014/main" val="20000"/>
-                    </a:ext>
-                  </a:extLst>
-                </a:gridCol>
-                <a:gridCol w="6126480">
-                  <a:extLst>
-                    <a:ext uri="{9D8B030D-6E8A-4147-A177-3AD203B41FA5}">
-                      <a16:colId xmlns:a16="http://schemas.microsoft.com/office/drawing/2014/main" val="20001"/>
-                    </a:ext>
-                  </a:extLst>
-                </a:gridCol>
+                <a:gridCol w="3108960"/>
+                <a:gridCol w="6126480"/>
               </a:tblGrid>
               <a:tr h="566928">
                 <a:tc>
@@ -6174,7 +6421,7 @@
                     <a:bodyPr/>
                     <a:lstStyle/>
                     <a:p>
-                      <a:pPr marL="0" indent="0">
+                      <a:pPr indent="0" marL="0">
                         <a:buNone/>
                       </a:pPr>
                       <a:r>
@@ -6195,7 +6442,7 @@
                       </a:endParaRPr>
                     </a:p>
                   </a:txBody>
-                  <a:tcPr anchor="ctr">
+                  <a:tcPr marL="91440" marR="91440" marT="45720" marB="45720" anchor="ctr">
                     <a:lnL w="6350" cap="flat" cmpd="sng" algn="ctr">
                       <a:solidFill>
                         <a:srgbClr val="CBD2D9"/>
@@ -6242,7 +6489,7 @@
                     <a:bodyPr/>
                     <a:lstStyle/>
                     <a:p>
-                      <a:pPr marL="0" indent="0">
+                      <a:pPr indent="0" marL="0">
                         <a:buNone/>
                       </a:pPr>
                       <a:r>
@@ -6263,7 +6510,7 @@
                       </a:endParaRPr>
                     </a:p>
                   </a:txBody>
-                  <a:tcPr anchor="ctr">
+                  <a:tcPr marL="91440" marR="91440" marT="45720" marB="45720" anchor="ctr">
                     <a:lnL w="6350" cap="flat" cmpd="sng" algn="ctr">
                       <a:solidFill>
                         <a:srgbClr val="CBD2D9"/>
@@ -6305,11 +6552,6 @@
                     </a:solidFill>
                   </a:tcPr>
                 </a:tc>
-                <a:extLst>
-                  <a:ext uri="{0D108BD9-81ED-4DB2-BD59-A6C34878D82A}">
-                    <a16:rowId xmlns:a16="http://schemas.microsoft.com/office/drawing/2014/main" val="10000"/>
-                  </a:ext>
-                </a:extLst>
               </a:tr>
               <a:tr h="566928">
                 <a:tc>
@@ -6317,7 +6559,7 @@
                     <a:bodyPr/>
                     <a:lstStyle/>
                     <a:p>
-                      <a:pPr marL="0" indent="0">
+                      <a:pPr indent="0" marL="0">
                         <a:buNone/>
                       </a:pPr>
                       <a:r>
@@ -6338,7 +6580,7 @@
                       </a:endParaRPr>
                     </a:p>
                   </a:txBody>
-                  <a:tcPr anchor="ctr">
+                  <a:tcPr marL="91440" marR="91440" marT="45720" marB="45720" anchor="ctr">
                     <a:lnL w="6350" cap="flat" cmpd="sng" algn="ctr">
                       <a:solidFill>
                         <a:srgbClr val="CBD2D9"/>
@@ -6382,7 +6624,7 @@
                     <a:bodyPr/>
                     <a:lstStyle/>
                     <a:p>
-                      <a:pPr marL="0" indent="0">
+                      <a:pPr indent="0" marL="0">
                         <a:buNone/>
                       </a:pPr>
                       <a:r>
@@ -6403,7 +6645,7 @@
                       </a:endParaRPr>
                     </a:p>
                   </a:txBody>
-                  <a:tcPr anchor="ctr">
+                  <a:tcPr marL="91440" marR="91440" marT="45720" marB="45720" anchor="ctr">
                     <a:lnL w="6350" cap="flat" cmpd="sng" algn="ctr">
                       <a:solidFill>
                         <a:srgbClr val="CBD2D9"/>
@@ -6442,11 +6684,6 @@
                     </a:lnB>
                   </a:tcPr>
                 </a:tc>
-                <a:extLst>
-                  <a:ext uri="{0D108BD9-81ED-4DB2-BD59-A6C34878D82A}">
-                    <a16:rowId xmlns:a16="http://schemas.microsoft.com/office/drawing/2014/main" val="10001"/>
-                  </a:ext>
-                </a:extLst>
               </a:tr>
               <a:tr h="566928">
                 <a:tc>
@@ -6454,7 +6691,7 @@
                     <a:bodyPr/>
                     <a:lstStyle/>
                     <a:p>
-                      <a:pPr marL="0" indent="0">
+                      <a:pPr indent="0" marL="0">
                         <a:buNone/>
                       </a:pPr>
                       <a:r>
@@ -6475,7 +6712,7 @@
                       </a:endParaRPr>
                     </a:p>
                   </a:txBody>
-                  <a:tcPr anchor="ctr">
+                  <a:tcPr marL="91440" marR="91440" marT="45720" marB="45720" anchor="ctr">
                     <a:lnL w="6350" cap="flat" cmpd="sng" algn="ctr">
                       <a:solidFill>
                         <a:srgbClr val="CBD2D9"/>
@@ -6519,7 +6756,7 @@
                     <a:bodyPr/>
                     <a:lstStyle/>
                     <a:p>
-                      <a:pPr marL="0" indent="0">
+                      <a:pPr indent="0" marL="0">
                         <a:buNone/>
                       </a:pPr>
                       <a:r>
@@ -6540,7 +6777,7 @@
                       </a:endParaRPr>
                     </a:p>
                   </a:txBody>
-                  <a:tcPr anchor="ctr">
+                  <a:tcPr marL="91440" marR="91440" marT="45720" marB="45720" anchor="ctr">
                     <a:lnL w="6350" cap="flat" cmpd="sng" algn="ctr">
                       <a:solidFill>
                         <a:srgbClr val="CBD2D9"/>
@@ -6579,11 +6816,6 @@
                     </a:lnB>
                   </a:tcPr>
                 </a:tc>
-                <a:extLst>
-                  <a:ext uri="{0D108BD9-81ED-4DB2-BD59-A6C34878D82A}">
-                    <a16:rowId xmlns:a16="http://schemas.microsoft.com/office/drawing/2014/main" val="10002"/>
-                  </a:ext>
-                </a:extLst>
               </a:tr>
               <a:tr h="566928">
                 <a:tc>
@@ -6591,7 +6823,7 @@
                     <a:bodyPr/>
                     <a:lstStyle/>
                     <a:p>
-                      <a:pPr marL="0" indent="0">
+                      <a:pPr indent="0" marL="0">
                         <a:buNone/>
                       </a:pPr>
                       <a:r>
@@ -6612,7 +6844,7 @@
                       </a:endParaRPr>
                     </a:p>
                   </a:txBody>
-                  <a:tcPr anchor="ctr">
+                  <a:tcPr marL="91440" marR="91440" marT="45720" marB="45720" anchor="ctr">
                     <a:lnL w="6350" cap="flat" cmpd="sng" algn="ctr">
                       <a:solidFill>
                         <a:srgbClr val="CBD2D9"/>
@@ -6656,7 +6888,7 @@
                     <a:bodyPr/>
                     <a:lstStyle/>
                     <a:p>
-                      <a:pPr marL="0" indent="0">
+                      <a:pPr indent="0" marL="0">
                         <a:buNone/>
                       </a:pPr>
                       <a:r>
@@ -6677,7 +6909,7 @@
                       </a:endParaRPr>
                     </a:p>
                   </a:txBody>
-                  <a:tcPr anchor="ctr">
+                  <a:tcPr marL="91440" marR="91440" marT="45720" marB="45720" anchor="ctr">
                     <a:lnL w="6350" cap="flat" cmpd="sng" algn="ctr">
                       <a:solidFill>
                         <a:srgbClr val="CBD2D9"/>
@@ -6716,11 +6948,6 @@
                     </a:lnB>
                   </a:tcPr>
                 </a:tc>
-                <a:extLst>
-                  <a:ext uri="{0D108BD9-81ED-4DB2-BD59-A6C34878D82A}">
-                    <a16:rowId xmlns:a16="http://schemas.microsoft.com/office/drawing/2014/main" val="10003"/>
-                  </a:ext>
-                </a:extLst>
               </a:tr>
               <a:tr h="566928">
                 <a:tc>
@@ -6728,7 +6955,7 @@
                     <a:bodyPr/>
                     <a:lstStyle/>
                     <a:p>
-                      <a:pPr marL="0" indent="0">
+                      <a:pPr indent="0" marL="0">
                         <a:buNone/>
                       </a:pPr>
                       <a:r>
@@ -6749,7 +6976,7 @@
                       </a:endParaRPr>
                     </a:p>
                   </a:txBody>
-                  <a:tcPr anchor="ctr">
+                  <a:tcPr marL="91440" marR="91440" marT="45720" marB="45720" anchor="ctr">
                     <a:lnL w="6350" cap="flat" cmpd="sng" algn="ctr">
                       <a:solidFill>
                         <a:srgbClr val="CBD2D9"/>
@@ -6793,7 +7020,7 @@
                     <a:bodyPr/>
                     <a:lstStyle/>
                     <a:p>
-                      <a:pPr marL="0" indent="0">
+                      <a:pPr indent="0" marL="0">
                         <a:buNone/>
                       </a:pPr>
                       <a:r>
@@ -6814,7 +7041,7 @@
                       </a:endParaRPr>
                     </a:p>
                   </a:txBody>
-                  <a:tcPr anchor="ctr">
+                  <a:tcPr marL="91440" marR="91440" marT="45720" marB="45720" anchor="ctr">
                     <a:lnL w="6350" cap="flat" cmpd="sng" algn="ctr">
                       <a:solidFill>
                         <a:srgbClr val="CBD2D9"/>
@@ -6853,11 +7080,6 @@
                     </a:lnB>
                   </a:tcPr>
                 </a:tc>
-                <a:extLst>
-                  <a:ext uri="{0D108BD9-81ED-4DB2-BD59-A6C34878D82A}">
-                    <a16:rowId xmlns:a16="http://schemas.microsoft.com/office/drawing/2014/main" val="10004"/>
-                  </a:ext>
-                </a:extLst>
               </a:tr>
             </a:tbl>
           </a:graphicData>
@@ -6884,7 +7106,7 @@
           <a:bodyPr wrap="square" lIns="0" tIns="0" rIns="0" bIns="0" rtlCol="0" anchor="t"/>
           <a:lstStyle/>
           <a:p>
-            <a:pPr marL="0" indent="0">
+            <a:pPr indent="0" marL="0">
               <a:buNone/>
             </a:pPr>
             <a:r>
@@ -6918,7 +7140,6 @@
         <a:solidFill>
           <a:srgbClr val="FFFFFF"/>
         </a:solidFill>
-        <a:effectLst/>
       </p:bgPr>
     </p:bg>
     <p:spTree>
@@ -6956,11 +7177,11 @@
           <a:bodyPr wrap="square" lIns="0" tIns="0" rIns="0" bIns="0" rtlCol="0" anchor="ctr"/>
           <a:lstStyle/>
           <a:p>
-            <a:pPr marL="0" indent="0">
+            <a:pPr indent="0" marL="0">
               <a:buNone/>
             </a:pPr>
             <a:r>
-              <a:rPr lang="en-US" sz="1100" b="1" kern="0" spc="300" dirty="0">
+              <a:rPr lang="en-US" sz="1100" b="1" spc="300" kern="0" dirty="0">
                 <a:solidFill>
                   <a:srgbClr val="0E7C86"/>
                 </a:solidFill>
@@ -6995,7 +7216,7 @@
           <a:bodyPr wrap="square" lIns="0" tIns="0" rIns="0" bIns="0" rtlCol="0" anchor="t"/>
           <a:lstStyle/>
           <a:p>
-            <a:pPr marL="0" indent="0">
+            <a:pPr indent="0" marL="0">
               <a:buNone/>
             </a:pPr>
             <a:r>
@@ -7029,27 +7250,15 @@
         </p:nvGraphicFramePr>
         <p:xfrm>
           <a:off x="1463040" y="2468880"/>
-          <a:ext cx="9235440" cy="2834640"/>
+          <a:ext cx="9235440" cy="2651760"/>
         </p:xfrm>
         <a:graphic>
           <a:graphicData uri="http://schemas.openxmlformats.org/drawingml/2006/table">
             <a:tbl>
               <a:tblPr/>
               <a:tblGrid>
-                <a:gridCol w="3108960">
-                  <a:extLst>
-                    <a:ext uri="{9D8B030D-6E8A-4147-A177-3AD203B41FA5}">
-                      <a16:colId xmlns:a16="http://schemas.microsoft.com/office/drawing/2014/main" val="20000"/>
-                    </a:ext>
-                  </a:extLst>
-                </a:gridCol>
-                <a:gridCol w="6126480">
-                  <a:extLst>
-                    <a:ext uri="{9D8B030D-6E8A-4147-A177-3AD203B41FA5}">
-                      <a16:colId xmlns:a16="http://schemas.microsoft.com/office/drawing/2014/main" val="20001"/>
-                    </a:ext>
-                  </a:extLst>
-                </a:gridCol>
+                <a:gridCol w="3108960"/>
+                <a:gridCol w="6126480"/>
               </a:tblGrid>
               <a:tr h="566928">
                 <a:tc>
@@ -7057,7 +7266,7 @@
                     <a:bodyPr/>
                     <a:lstStyle/>
                     <a:p>
-                      <a:pPr marL="0" indent="0">
+                      <a:pPr indent="0" marL="0">
                         <a:buNone/>
                       </a:pPr>
                       <a:r>
@@ -7078,7 +7287,7 @@
                       </a:endParaRPr>
                     </a:p>
                   </a:txBody>
-                  <a:tcPr anchor="ctr">
+                  <a:tcPr marL="91440" marR="91440" marT="45720" marB="45720" anchor="ctr">
                     <a:lnL w="6350" cap="flat" cmpd="sng" algn="ctr">
                       <a:solidFill>
                         <a:srgbClr val="CBD2D9"/>
@@ -7125,7 +7334,7 @@
                     <a:bodyPr/>
                     <a:lstStyle/>
                     <a:p>
-                      <a:pPr marL="0" indent="0">
+                      <a:pPr indent="0" marL="0">
                         <a:buNone/>
                       </a:pPr>
                       <a:r>
@@ -7146,7 +7355,7 @@
                       </a:endParaRPr>
                     </a:p>
                   </a:txBody>
-                  <a:tcPr anchor="ctr">
+                  <a:tcPr marL="91440" marR="91440" marT="45720" marB="45720" anchor="ctr">
                     <a:lnL w="6350" cap="flat" cmpd="sng" algn="ctr">
                       <a:solidFill>
                         <a:srgbClr val="CBD2D9"/>
@@ -7188,11 +7397,6 @@
                     </a:solidFill>
                   </a:tcPr>
                 </a:tc>
-                <a:extLst>
-                  <a:ext uri="{0D108BD9-81ED-4DB2-BD59-A6C34878D82A}">
-                    <a16:rowId xmlns:a16="http://schemas.microsoft.com/office/drawing/2014/main" val="10000"/>
-                  </a:ext>
-                </a:extLst>
               </a:tr>
               <a:tr h="566928">
                 <a:tc>
@@ -7200,7 +7404,7 @@
                     <a:bodyPr/>
                     <a:lstStyle/>
                     <a:p>
-                      <a:pPr marL="0" indent="0">
+                      <a:pPr indent="0" marL="0">
                         <a:buNone/>
                       </a:pPr>
                       <a:r>
@@ -7221,7 +7425,7 @@
                       </a:endParaRPr>
                     </a:p>
                   </a:txBody>
-                  <a:tcPr anchor="ctr">
+                  <a:tcPr marL="91440" marR="91440" marT="45720" marB="45720" anchor="ctr">
                     <a:lnL w="6350" cap="flat" cmpd="sng" algn="ctr">
                       <a:solidFill>
                         <a:srgbClr val="CBD2D9"/>
@@ -7265,7 +7469,7 @@
                     <a:bodyPr/>
                     <a:lstStyle/>
                     <a:p>
-                      <a:pPr marL="0" indent="0">
+                      <a:pPr indent="0" marL="0">
                         <a:buNone/>
                       </a:pPr>
                       <a:r>
@@ -7286,7 +7490,7 @@
                       </a:endParaRPr>
                     </a:p>
                   </a:txBody>
-                  <a:tcPr anchor="ctr">
+                  <a:tcPr marL="91440" marR="91440" marT="45720" marB="45720" anchor="ctr">
                     <a:lnL w="6350" cap="flat" cmpd="sng" algn="ctr">
                       <a:solidFill>
                         <a:srgbClr val="CBD2D9"/>
@@ -7325,11 +7529,6 @@
                     </a:lnB>
                   </a:tcPr>
                 </a:tc>
-                <a:extLst>
-                  <a:ext uri="{0D108BD9-81ED-4DB2-BD59-A6C34878D82A}">
-                    <a16:rowId xmlns:a16="http://schemas.microsoft.com/office/drawing/2014/main" val="10001"/>
-                  </a:ext>
-                </a:extLst>
               </a:tr>
               <a:tr h="566928">
                 <a:tc>
@@ -7337,7 +7536,7 @@
                     <a:bodyPr/>
                     <a:lstStyle/>
                     <a:p>
-                      <a:pPr marL="0" indent="0">
+                      <a:pPr indent="0" marL="0">
                         <a:buNone/>
                       </a:pPr>
                       <a:r>
@@ -7358,7 +7557,7 @@
                       </a:endParaRPr>
                     </a:p>
                   </a:txBody>
-                  <a:tcPr anchor="ctr">
+                  <a:tcPr marL="91440" marR="91440" marT="45720" marB="45720" anchor="ctr">
                     <a:lnL w="6350" cap="flat" cmpd="sng" algn="ctr">
                       <a:solidFill>
                         <a:srgbClr val="CBD2D9"/>
@@ -7402,7 +7601,7 @@
                     <a:bodyPr/>
                     <a:lstStyle/>
                     <a:p>
-                      <a:pPr marL="0" indent="0">
+                      <a:pPr indent="0" marL="0">
                         <a:buNone/>
                       </a:pPr>
                       <a:r>
@@ -7423,7 +7622,7 @@
                       </a:endParaRPr>
                     </a:p>
                   </a:txBody>
-                  <a:tcPr anchor="ctr">
+                  <a:tcPr marL="91440" marR="91440" marT="45720" marB="45720" anchor="ctr">
                     <a:lnL w="6350" cap="flat" cmpd="sng" algn="ctr">
                       <a:solidFill>
                         <a:srgbClr val="CBD2D9"/>
@@ -7462,11 +7661,6 @@
                     </a:lnB>
                   </a:tcPr>
                 </a:tc>
-                <a:extLst>
-                  <a:ext uri="{0D108BD9-81ED-4DB2-BD59-A6C34878D82A}">
-                    <a16:rowId xmlns:a16="http://schemas.microsoft.com/office/drawing/2014/main" val="10002"/>
-                  </a:ext>
-                </a:extLst>
               </a:tr>
               <a:tr h="566928">
                 <a:tc>
@@ -7474,7 +7668,7 @@
                     <a:bodyPr/>
                     <a:lstStyle/>
                     <a:p>
-                      <a:pPr marL="0" indent="0">
+                      <a:pPr indent="0" marL="0">
                         <a:buNone/>
                       </a:pPr>
                       <a:r>
@@ -7495,7 +7689,7 @@
                       </a:endParaRPr>
                     </a:p>
                   </a:txBody>
-                  <a:tcPr anchor="ctr">
+                  <a:tcPr marL="91440" marR="91440" marT="45720" marB="45720" anchor="ctr">
                     <a:lnL w="6350" cap="flat" cmpd="sng" algn="ctr">
                       <a:solidFill>
                         <a:srgbClr val="CBD2D9"/>
@@ -7539,7 +7733,7 @@
                     <a:bodyPr/>
                     <a:lstStyle/>
                     <a:p>
-                      <a:pPr marL="0" indent="0">
+                      <a:pPr indent="0" marL="0">
                         <a:buNone/>
                       </a:pPr>
                       <a:r>
@@ -7560,7 +7754,7 @@
                       </a:endParaRPr>
                     </a:p>
                   </a:txBody>
-                  <a:tcPr anchor="ctr">
+                  <a:tcPr marL="91440" marR="91440" marT="45720" marB="45720" anchor="ctr">
                     <a:lnL w="6350" cap="flat" cmpd="sng" algn="ctr">
                       <a:solidFill>
                         <a:srgbClr val="CBD2D9"/>
@@ -7599,11 +7793,6 @@
                     </a:lnB>
                   </a:tcPr>
                 </a:tc>
-                <a:extLst>
-                  <a:ext uri="{0D108BD9-81ED-4DB2-BD59-A6C34878D82A}">
-                    <a16:rowId xmlns:a16="http://schemas.microsoft.com/office/drawing/2014/main" val="10003"/>
-                  </a:ext>
-                </a:extLst>
               </a:tr>
               <a:tr h="566928">
                 <a:tc>
@@ -7611,7 +7800,7 @@
                     <a:bodyPr/>
                     <a:lstStyle/>
                     <a:p>
-                      <a:pPr marL="0" indent="0">
+                      <a:pPr indent="0" marL="0">
                         <a:buNone/>
                       </a:pPr>
                       <a:r>
@@ -7632,7 +7821,7 @@
                       </a:endParaRPr>
                     </a:p>
                   </a:txBody>
-                  <a:tcPr anchor="ctr">
+                  <a:tcPr marL="91440" marR="91440" marT="45720" marB="45720" anchor="ctr">
                     <a:lnL w="6350" cap="flat" cmpd="sng" algn="ctr">
                       <a:solidFill>
                         <a:srgbClr val="CBD2D9"/>
@@ -7676,7 +7865,7 @@
                     <a:bodyPr/>
                     <a:lstStyle/>
                     <a:p>
-                      <a:pPr marL="0" indent="0">
+                      <a:pPr indent="0" marL="0">
                         <a:buNone/>
                       </a:pPr>
                       <a:r>
@@ -7697,7 +7886,7 @@
                       </a:endParaRPr>
                     </a:p>
                   </a:txBody>
-                  <a:tcPr anchor="ctr">
+                  <a:tcPr marL="91440" marR="91440" marT="45720" marB="45720" anchor="ctr">
                     <a:lnL w="6350" cap="flat" cmpd="sng" algn="ctr">
                       <a:solidFill>
                         <a:srgbClr val="CBD2D9"/>
@@ -7736,11 +7925,6 @@
                     </a:lnB>
                   </a:tcPr>
                 </a:tc>
-                <a:extLst>
-                  <a:ext uri="{0D108BD9-81ED-4DB2-BD59-A6C34878D82A}">
-                    <a16:rowId xmlns:a16="http://schemas.microsoft.com/office/drawing/2014/main" val="10004"/>
-                  </a:ext>
-                </a:extLst>
               </a:tr>
             </a:tbl>
           </a:graphicData>
@@ -7767,7 +7951,7 @@
           <a:bodyPr wrap="square" lIns="0" tIns="0" rIns="0" bIns="0" rtlCol="0" anchor="t"/>
           <a:lstStyle/>
           <a:p>
-            <a:pPr marL="0" indent="0">
+            <a:pPr indent="0" marL="0">
               <a:buNone/>
             </a:pPr>
             <a:r>
@@ -7801,7 +7985,6 @@
         <a:solidFill>
           <a:srgbClr val="FFFFFF"/>
         </a:solidFill>
-        <a:effectLst/>
       </p:bgPr>
     </p:bg>
     <p:spTree>
@@ -7839,11 +8022,11 @@
           <a:bodyPr wrap="square" lIns="0" tIns="0" rIns="0" bIns="0" rtlCol="0" anchor="ctr"/>
           <a:lstStyle/>
           <a:p>
-            <a:pPr marL="0" indent="0">
+            <a:pPr indent="0" marL="0">
               <a:buNone/>
             </a:pPr>
             <a:r>
-              <a:rPr lang="en-US" sz="1100" b="1" kern="0" spc="300" dirty="0">
+              <a:rPr lang="en-US" sz="1100" b="1" spc="300" kern="0" dirty="0">
                 <a:solidFill>
                   <a:srgbClr val="0E7C86"/>
                 </a:solidFill>
@@ -7878,7 +8061,7 @@
           <a:bodyPr wrap="square" lIns="0" tIns="0" rIns="0" bIns="0" rtlCol="0" anchor="t"/>
           <a:lstStyle/>
           <a:p>
-            <a:pPr marL="0" indent="0">
+            <a:pPr indent="0" marL="0">
               <a:buNone/>
             </a:pPr>
             <a:r>
@@ -7917,7 +8100,7 @@
           <a:bodyPr wrap="square" lIns="0" tIns="0" rIns="0" bIns="0" rtlCol="0" anchor="t"/>
           <a:lstStyle/>
           <a:p>
-            <a:pPr marL="0" indent="0">
+            <a:pPr indent="0" marL="0">
               <a:buNone/>
             </a:pPr>
             <a:r>
@@ -7937,14 +8120,14 @@
       </p:sp>
       <p:pic>
         <p:nvPicPr>
-          <p:cNvPr id="5" name="Image 0" descr="/sessions/youthful-relaxed-maxwell/mnt/OHT_MAPF/results/assets/fig_dependency.png"/>
+          <p:cNvPr id="5" name="Image 0" descr="/sessions/youthful-relaxed-maxwell/mnt/OHT_MAPF/results/assets/fig_dependency.png">    </p:cNvPr>
           <p:cNvPicPr>
             <a:picLocks noChangeAspect="1"/>
           </p:cNvPicPr>
           <p:nvPr/>
         </p:nvPicPr>
         <p:blipFill>
-          <a:blip r:embed="rId3"/>
+          <a:blip r:embed="rId1"/>
           <a:stretch>
             <a:fillRect/>
           </a:stretch>
@@ -7975,7 +8158,6 @@
         <a:solidFill>
           <a:srgbClr val="FFFFFF"/>
         </a:solidFill>
-        <a:effectLst/>
       </p:bgPr>
     </p:bg>
     <p:spTree>
@@ -8013,11 +8195,11 @@
           <a:bodyPr wrap="square" lIns="0" tIns="0" rIns="0" bIns="0" rtlCol="0" anchor="ctr"/>
           <a:lstStyle/>
           <a:p>
-            <a:pPr marL="0" indent="0">
+            <a:pPr indent="0" marL="0">
               <a:buNone/>
             </a:pPr>
             <a:r>
-              <a:rPr lang="en-US" sz="1100" b="1" kern="0" spc="300" dirty="0">
+              <a:rPr lang="en-US" sz="1100" b="1" spc="300" kern="0" dirty="0">
                 <a:solidFill>
                   <a:srgbClr val="0E7C86"/>
                 </a:solidFill>
@@ -8052,7 +8234,7 @@
           <a:bodyPr wrap="square" lIns="0" tIns="0" rIns="0" bIns="0" rtlCol="0" anchor="t"/>
           <a:lstStyle/>
           <a:p>
-            <a:pPr marL="0" indent="0">
+            <a:pPr indent="0" marL="0">
               <a:buNone/>
             </a:pPr>
             <a:r>
@@ -8091,7 +8273,7 @@
           <a:bodyPr wrap="square" lIns="0" tIns="0" rIns="0" bIns="0" rtlCol="0" anchor="t"/>
           <a:lstStyle/>
           <a:p>
-            <a:pPr marL="0" indent="0">
+            <a:pPr indent="0" marL="0">
               <a:buNone/>
             </a:pPr>
             <a:r>
@@ -8111,14 +8293,14 @@
       </p:sp>
       <p:pic>
         <p:nvPicPr>
-          <p:cNvPr id="5" name="Image 0" descr="/sessions/youthful-relaxed-maxwell/mnt/OHT_MAPF/results/assets/data_h.png"/>
+          <p:cNvPr id="5" name="Image 0" descr="/sessions/youthful-relaxed-maxwell/mnt/OHT_MAPF/results/assets/data_h.png">    </p:cNvPr>
           <p:cNvPicPr>
             <a:picLocks noChangeAspect="1"/>
           </p:cNvPicPr>
           <p:nvPr/>
         </p:nvPicPr>
         <p:blipFill>
-          <a:blip r:embed="rId3"/>
+          <a:blip r:embed="rId1"/>
           <a:stretch>
             <a:fillRect/>
           </a:stretch>
@@ -8149,7 +8331,6 @@
         <a:solidFill>
           <a:srgbClr val="FFFFFF"/>
         </a:solidFill>
-        <a:effectLst/>
       </p:bgPr>
     </p:bg>
     <p:spTree>
@@ -8187,11 +8368,11 @@
           <a:bodyPr wrap="square" lIns="0" tIns="0" rIns="0" bIns="0" rtlCol="0" anchor="ctr"/>
           <a:lstStyle/>
           <a:p>
-            <a:pPr marL="0" indent="0">
+            <a:pPr indent="0" marL="0">
               <a:buNone/>
             </a:pPr>
             <a:r>
-              <a:rPr lang="en-US" sz="1100" b="1" kern="0" spc="300" dirty="0">
+              <a:rPr lang="en-US" sz="1100" b="1" spc="300" kern="0" dirty="0">
                 <a:solidFill>
                   <a:srgbClr val="0E7C86"/>
                 </a:solidFill>
@@ -8226,7 +8407,7 @@
           <a:bodyPr wrap="square" lIns="0" tIns="0" rIns="0" bIns="0" rtlCol="0" anchor="t"/>
           <a:lstStyle/>
           <a:p>
-            <a:pPr marL="0" indent="0">
+            <a:pPr indent="0" marL="0">
               <a:buNone/>
             </a:pPr>
             <a:r>
@@ -8265,7 +8446,7 @@
           <a:bodyPr wrap="square" lIns="0" tIns="0" rIns="0" bIns="0" rtlCol="0" anchor="t"/>
           <a:lstStyle/>
           <a:p>
-            <a:pPr marL="0" indent="0">
+            <a:pPr indent="0" marL="0">
               <a:buNone/>
             </a:pPr>
             <a:r>
@@ -8285,14 +8466,14 @@
       </p:sp>
       <p:pic>
         <p:nvPicPr>
-          <p:cNvPr id="5" name="Image 0" descr="/sessions/youthful-relaxed-maxwell/mnt/OHT_MAPF/results/assets/interval.png"/>
+          <p:cNvPr id="5" name="Image 0" descr="/sessions/youthful-relaxed-maxwell/mnt/OHT_MAPF/results/assets/interval.png">    </p:cNvPr>
           <p:cNvPicPr>
             <a:picLocks noChangeAspect="1"/>
           </p:cNvPicPr>
           <p:nvPr/>
         </p:nvPicPr>
         <p:blipFill>
-          <a:blip r:embed="rId3"/>
+          <a:blip r:embed="rId1"/>
           <a:stretch>
             <a:fillRect/>
           </a:stretch>
@@ -8309,14 +8490,14 @@
       </p:pic>
       <p:pic>
         <p:nvPicPr>
-          <p:cNvPr id="6" name="Image 1" descr="/sessions/youthful-relaxed-maxwell/mnt/OHT_MAPF/results/assets/agent_operator_overloading.png"/>
+          <p:cNvPr id="6" name="Image 1" descr="/sessions/youthful-relaxed-maxwell/mnt/OHT_MAPF/results/assets/agent_operator_overloading.png">    </p:cNvPr>
           <p:cNvPicPr>
             <a:picLocks noChangeAspect="1"/>
           </p:cNvPicPr>
           <p:nvPr/>
         </p:nvPicPr>
         <p:blipFill>
-          <a:blip r:embed="rId4"/>
+          <a:blip r:embed="rId2"/>
           <a:stretch>
             <a:fillRect/>
           </a:stretch>
@@ -8352,7 +8533,7 @@
           <a:bodyPr wrap="square" lIns="0" tIns="0" rIns="0" bIns="0" rtlCol="0" anchor="ctr"/>
           <a:lstStyle/>
           <a:p>
-            <a:pPr marL="0" indent="0">
+            <a:pPr indent="0" marL="0">
               <a:buNone/>
             </a:pPr>
             <a:r>
@@ -8386,7 +8567,6 @@
         <a:solidFill>
           <a:srgbClr val="FFFFFF"/>
         </a:solidFill>
-        <a:effectLst/>
       </p:bgPr>
     </p:bg>
     <p:spTree>
@@ -8424,11 +8604,11 @@
           <a:bodyPr wrap="square" lIns="0" tIns="0" rIns="0" bIns="0" rtlCol="0" anchor="ctr"/>
           <a:lstStyle/>
           <a:p>
-            <a:pPr marL="0" indent="0">
+            <a:pPr indent="0" marL="0">
               <a:buNone/>
             </a:pPr>
             <a:r>
-              <a:rPr lang="en-US" sz="1100" b="1" kern="0" spc="300" dirty="0">
+              <a:rPr lang="en-US" sz="1100" b="1" spc="300" kern="0" dirty="0">
                 <a:solidFill>
                   <a:srgbClr val="0E7C86"/>
                 </a:solidFill>
@@ -8463,7 +8643,7 @@
           <a:bodyPr wrap="square" lIns="0" tIns="0" rIns="0" bIns="0" rtlCol="0" anchor="t"/>
           <a:lstStyle/>
           <a:p>
-            <a:pPr marL="0" indent="0">
+            <a:pPr indent="0" marL="0">
               <a:buNone/>
             </a:pPr>
             <a:r>
@@ -8502,7 +8682,7 @@
           <a:bodyPr wrap="square" lIns="0" tIns="0" rIns="0" bIns="0" rtlCol="0" anchor="t"/>
           <a:lstStyle/>
           <a:p>
-            <a:pPr marL="0" indent="0">
+            <a:pPr indent="0" marL="0">
               <a:buNone/>
             </a:pPr>
             <a:r>
@@ -8522,14 +8702,14 @@
       </p:sp>
       <p:pic>
         <p:nvPicPr>
-          <p:cNvPr id="5" name="Image 0" descr="/sessions/youthful-relaxed-maxwell/mnt/OHT_MAPF/results/assets/fig_adjlist.png"/>
+          <p:cNvPr id="5" name="Image 0" descr="/sessions/youthful-relaxed-maxwell/mnt/OHT_MAPF/results/assets/fig_adjlist.png">    </p:cNvPr>
           <p:cNvPicPr>
             <a:picLocks noChangeAspect="1"/>
           </p:cNvPicPr>
           <p:nvPr/>
         </p:nvPicPr>
         <p:blipFill>
-          <a:blip r:embed="rId3"/>
+          <a:blip r:embed="rId1"/>
           <a:stretch>
             <a:fillRect/>
           </a:stretch>
@@ -8560,7 +8740,6 @@
         <a:solidFill>
           <a:srgbClr val="FFFFFF"/>
         </a:solidFill>
-        <a:effectLst/>
       </p:bgPr>
     </p:bg>
     <p:spTree>
@@ -8598,11 +8777,11 @@
           <a:bodyPr wrap="square" lIns="0" tIns="0" rIns="0" bIns="0" rtlCol="0" anchor="ctr"/>
           <a:lstStyle/>
           <a:p>
-            <a:pPr marL="0" indent="0">
+            <a:pPr indent="0" marL="0">
               <a:buNone/>
             </a:pPr>
             <a:r>
-              <a:rPr lang="en-US" sz="1100" b="1" kern="0" spc="300" dirty="0">
+              <a:rPr lang="en-US" sz="1100" b="1" spc="300" kern="0" dirty="0">
                 <a:solidFill>
                   <a:srgbClr val="0E7C86"/>
                 </a:solidFill>
@@ -8637,7 +8816,7 @@
           <a:bodyPr wrap="square" lIns="0" tIns="0" rIns="0" bIns="0" rtlCol="0" anchor="t"/>
           <a:lstStyle/>
           <a:p>
-            <a:pPr marL="0" indent="0">
+            <a:pPr indent="0" marL="0">
               <a:buNone/>
             </a:pPr>
             <a:r>
@@ -8676,7 +8855,7 @@
           <a:bodyPr wrap="square" lIns="0" tIns="0" rIns="0" bIns="0" rtlCol="0" anchor="t"/>
           <a:lstStyle/>
           <a:p>
-            <a:pPr marL="0" indent="0">
+            <a:pPr indent="0" marL="0">
               <a:buNone/>
             </a:pPr>
             <a:r>
@@ -8696,14 +8875,14 @@
       </p:sp>
       <p:pic>
         <p:nvPicPr>
-          <p:cNvPr id="5" name="Image 0" descr="/sessions/youthful-relaxed-maxwell/mnt/OHT_MAPF/results/assets/FAB_OHT.png"/>
+          <p:cNvPr id="5" name="Image 0" descr="/sessions/youthful-relaxed-maxwell/mnt/OHT_MAPF/results/assets/FAB_OHT.png">    </p:cNvPr>
           <p:cNvPicPr>
             <a:picLocks noChangeAspect="1"/>
           </p:cNvPicPr>
           <p:nvPr/>
         </p:nvPicPr>
         <p:blipFill>
-          <a:blip r:embed="rId3"/>
+          <a:blip r:embed="rId1"/>
           <a:stretch>
             <a:fillRect/>
           </a:stretch>
@@ -8734,7 +8913,6 @@
         <a:solidFill>
           <a:srgbClr val="FFFFFF"/>
         </a:solidFill>
-        <a:effectLst/>
       </p:bgPr>
     </p:bg>
     <p:spTree>
@@ -8772,11 +8950,11 @@
           <a:bodyPr wrap="square" lIns="0" tIns="0" rIns="0" bIns="0" rtlCol="0" anchor="ctr"/>
           <a:lstStyle/>
           <a:p>
-            <a:pPr marL="0" indent="0">
+            <a:pPr indent="0" marL="0">
               <a:buNone/>
             </a:pPr>
             <a:r>
-              <a:rPr lang="en-US" sz="1100" b="1" kern="0" spc="300" dirty="0">
+              <a:rPr lang="en-US" sz="1100" b="1" spc="300" kern="0" dirty="0">
                 <a:solidFill>
                   <a:srgbClr val="0E7C86"/>
                 </a:solidFill>
@@ -8811,7 +8989,7 @@
           <a:bodyPr wrap="square" lIns="0" tIns="0" rIns="0" bIns="0" rtlCol="0" anchor="t"/>
           <a:lstStyle/>
           <a:p>
-            <a:pPr marL="0" indent="0">
+            <a:pPr indent="0" marL="0">
               <a:buNone/>
             </a:pPr>
             <a:r>
@@ -8831,14 +9009,14 @@
       </p:sp>
       <p:pic>
         <p:nvPicPr>
-          <p:cNvPr id="4" name="Image 0" descr="/sessions/youthful-relaxed-maxwell/mnt/OHT_MAPF/results/assets/graph.png"/>
+          <p:cNvPr id="4" name="Image 0" descr="/sessions/youthful-relaxed-maxwell/mnt/OHT_MAPF/results/assets/graph.png">    </p:cNvPr>
           <p:cNvPicPr>
             <a:picLocks noChangeAspect="1"/>
           </p:cNvPicPr>
           <p:nvPr/>
         </p:nvPicPr>
         <p:blipFill>
-          <a:blip r:embed="rId3"/>
+          <a:blip r:embed="rId1"/>
           <a:stretch>
             <a:fillRect/>
           </a:stretch>
@@ -8874,7 +9052,7 @@
           <a:bodyPr wrap="square" lIns="0" tIns="0" rIns="0" bIns="0" rtlCol="0" anchor="ctr"/>
           <a:lstStyle/>
           <a:p>
-            <a:pPr marL="0" indent="0">
+            <a:pPr indent="0" marL="0">
               <a:buNone/>
             </a:pPr>
             <a:r>
@@ -8931,7 +9109,7 @@
             <a:endParaRPr lang="en-US" sz="1500" dirty="0"/>
           </a:p>
           <a:p>
-            <a:pPr marL="0" indent="0">
+            <a:pPr indent="0" marL="0">
               <a:spcAft>
                 <a:spcPts val="1000"/>
               </a:spcAft>
@@ -8969,7 +9147,7 @@
             <a:endParaRPr lang="en-US" sz="1500" dirty="0"/>
           </a:p>
           <a:p>
-            <a:pPr marL="0" indent="0">
+            <a:pPr indent="0" marL="0">
               <a:spcAft>
                 <a:spcPts val="1000"/>
               </a:spcAft>
@@ -9007,7 +9185,7 @@
             <a:endParaRPr lang="en-US" sz="1500" dirty="0"/>
           </a:p>
           <a:p>
-            <a:pPr marL="0" indent="0">
+            <a:pPr indent="0" marL="0">
               <a:buNone/>
             </a:pPr>
             <a:r>
@@ -9041,7 +9219,6 @@
         <a:solidFill>
           <a:srgbClr val="FFFFFF"/>
         </a:solidFill>
-        <a:effectLst/>
       </p:bgPr>
     </p:bg>
     <p:spTree>
@@ -9079,11 +9256,11 @@
           <a:bodyPr wrap="square" lIns="0" tIns="0" rIns="0" bIns="0" rtlCol="0" anchor="ctr"/>
           <a:lstStyle/>
           <a:p>
-            <a:pPr marL="0" indent="0">
+            <a:pPr indent="0" marL="0">
               <a:buNone/>
             </a:pPr>
             <a:r>
-              <a:rPr lang="en-US" sz="1100" b="1" kern="0" spc="300" dirty="0">
+              <a:rPr lang="en-US" sz="1100" b="1" spc="300" kern="0" dirty="0">
                 <a:solidFill>
                   <a:srgbClr val="0E7C86"/>
                 </a:solidFill>
@@ -9118,7 +9295,7 @@
           <a:bodyPr wrap="square" lIns="0" tIns="0" rIns="0" bIns="0" rtlCol="0" anchor="t"/>
           <a:lstStyle/>
           <a:p>
-            <a:pPr marL="0" indent="0">
+            <a:pPr indent="0" marL="0">
               <a:buNone/>
             </a:pPr>
             <a:r>
@@ -9157,7 +9334,7 @@
           <a:bodyPr wrap="square" lIns="0" tIns="0" rIns="0" bIns="0" rtlCol="0" anchor="t"/>
           <a:lstStyle/>
           <a:p>
-            <a:pPr marL="0" indent="0">
+            <a:pPr indent="0" marL="0">
               <a:buNone/>
             </a:pPr>
             <a:r>
@@ -9177,14 +9354,14 @@
       </p:sp>
       <p:pic>
         <p:nvPicPr>
-          <p:cNvPr id="5" name="Image 0" descr="/sessions/youthful-relaxed-maxwell/mnt/OHT_MAPF/results/assets/fig_reservation.png"/>
+          <p:cNvPr id="5" name="Image 0" descr="/sessions/youthful-relaxed-maxwell/mnt/OHT_MAPF/results/assets/fig_reservation.png">    </p:cNvPr>
           <p:cNvPicPr>
             <a:picLocks noChangeAspect="1"/>
           </p:cNvPicPr>
           <p:nvPr/>
         </p:nvPicPr>
         <p:blipFill>
-          <a:blip r:embed="rId3"/>
+          <a:blip r:embed="rId1"/>
           <a:stretch>
             <a:fillRect/>
           </a:stretch>
@@ -9201,14 +9378,14 @@
       </p:pic>
       <p:pic>
         <p:nvPicPr>
-          <p:cNvPr id="6" name="Image 1" descr="/sessions/youthful-relaxed-maxwell/mnt/OHT_MAPF/results/assets/fig_coalesce.png"/>
+          <p:cNvPr id="6" name="Image 1" descr="/sessions/youthful-relaxed-maxwell/mnt/OHT_MAPF/results/assets/fig_coalesce.png">    </p:cNvPr>
           <p:cNvPicPr>
             <a:picLocks noChangeAspect="1"/>
           </p:cNvPicPr>
           <p:nvPr/>
         </p:nvPicPr>
         <p:blipFill>
-          <a:blip r:embed="rId4"/>
+          <a:blip r:embed="rId2"/>
           <a:stretch>
             <a:fillRect/>
           </a:stretch>
@@ -9239,7 +9416,6 @@
         <a:solidFill>
           <a:srgbClr val="FFFFFF"/>
         </a:solidFill>
-        <a:effectLst/>
       </p:bgPr>
     </p:bg>
     <p:spTree>
@@ -9277,11 +9453,11 @@
           <a:bodyPr wrap="square" lIns="0" tIns="0" rIns="0" bIns="0" rtlCol="0" anchor="ctr"/>
           <a:lstStyle/>
           <a:p>
-            <a:pPr marL="0" indent="0">
+            <a:pPr indent="0" marL="0">
               <a:buNone/>
             </a:pPr>
             <a:r>
-              <a:rPr lang="en-US" sz="1100" b="1" kern="0" spc="300" dirty="0">
+              <a:rPr lang="en-US" sz="1100" b="1" spc="300" kern="0" dirty="0">
                 <a:solidFill>
                   <a:srgbClr val="0E7C86"/>
                 </a:solidFill>
@@ -9316,7 +9492,7 @@
           <a:bodyPr wrap="square" lIns="0" tIns="0" rIns="0" bIns="0" rtlCol="0" anchor="t"/>
           <a:lstStyle/>
           <a:p>
-            <a:pPr marL="0" indent="0">
+            <a:pPr indent="0" marL="0">
               <a:buNone/>
             </a:pPr>
             <a:r>
@@ -9350,41 +9526,17 @@
         </p:nvGraphicFramePr>
         <p:xfrm>
           <a:off x="640080" y="2651760"/>
-          <a:ext cx="10881360" cy="2651760"/>
+          <a:ext cx="10881360" cy="2286000"/>
         </p:xfrm>
         <a:graphic>
           <a:graphicData uri="http://schemas.openxmlformats.org/drawingml/2006/table">
             <a:tbl>
               <a:tblPr/>
               <a:tblGrid>
-                <a:gridCol w="2377440">
-                  <a:extLst>
-                    <a:ext uri="{9D8B030D-6E8A-4147-A177-3AD203B41FA5}">
-                      <a16:colId xmlns:a16="http://schemas.microsoft.com/office/drawing/2014/main" val="20000"/>
-                    </a:ext>
-                  </a:extLst>
-                </a:gridCol>
-                <a:gridCol w="2377440">
-                  <a:extLst>
-                    <a:ext uri="{9D8B030D-6E8A-4147-A177-3AD203B41FA5}">
-                      <a16:colId xmlns:a16="http://schemas.microsoft.com/office/drawing/2014/main" val="20001"/>
-                    </a:ext>
-                  </a:extLst>
-                </a:gridCol>
-                <a:gridCol w="3383280">
-                  <a:extLst>
-                    <a:ext uri="{9D8B030D-6E8A-4147-A177-3AD203B41FA5}">
-                      <a16:colId xmlns:a16="http://schemas.microsoft.com/office/drawing/2014/main" val="20002"/>
-                    </a:ext>
-                  </a:extLst>
-                </a:gridCol>
-                <a:gridCol w="2743200">
-                  <a:extLst>
-                    <a:ext uri="{9D8B030D-6E8A-4147-A177-3AD203B41FA5}">
-                      <a16:colId xmlns:a16="http://schemas.microsoft.com/office/drawing/2014/main" val="20003"/>
-                    </a:ext>
-                  </a:extLst>
-                </a:gridCol>
+                <a:gridCol w="2377440"/>
+                <a:gridCol w="2377440"/>
+                <a:gridCol w="3383280"/>
+                <a:gridCol w="2743200"/>
               </a:tblGrid>
               <a:tr h="530352">
                 <a:tc>
@@ -9392,7 +9544,7 @@
                     <a:bodyPr/>
                     <a:lstStyle/>
                     <a:p>
-                      <a:pPr marL="0" indent="0">
+                      <a:pPr indent="0" marL="0">
                         <a:buNone/>
                       </a:pPr>
                       <a:r>
@@ -9413,7 +9565,7 @@
                       </a:endParaRPr>
                     </a:p>
                   </a:txBody>
-                  <a:tcPr anchor="ctr">
+                  <a:tcPr marL="91440" marR="91440" marT="45720" marB="45720" anchor="ctr">
                     <a:lnL w="6350" cap="flat" cmpd="sng" algn="ctr">
                       <a:solidFill>
                         <a:srgbClr val="CBD2D9"/>
@@ -9460,7 +9612,7 @@
                     <a:bodyPr/>
                     <a:lstStyle/>
                     <a:p>
-                      <a:pPr marL="0" indent="0">
+                      <a:pPr indent="0" marL="0">
                         <a:buNone/>
                       </a:pPr>
                       <a:r>
@@ -9481,7 +9633,7 @@
                       </a:endParaRPr>
                     </a:p>
                   </a:txBody>
-                  <a:tcPr anchor="ctr">
+                  <a:tcPr marL="91440" marR="91440" marT="45720" marB="45720" anchor="ctr">
                     <a:lnL w="6350" cap="flat" cmpd="sng" algn="ctr">
                       <a:solidFill>
                         <a:srgbClr val="CBD2D9"/>
@@ -9528,7 +9680,7 @@
                     <a:bodyPr/>
                     <a:lstStyle/>
                     <a:p>
-                      <a:pPr marL="0" indent="0">
+                      <a:pPr indent="0" marL="0">
                         <a:buNone/>
                       </a:pPr>
                       <a:r>
@@ -9549,7 +9701,7 @@
                       </a:endParaRPr>
                     </a:p>
                   </a:txBody>
-                  <a:tcPr anchor="ctr">
+                  <a:tcPr marL="91440" marR="91440" marT="45720" marB="45720" anchor="ctr">
                     <a:lnL w="6350" cap="flat" cmpd="sng" algn="ctr">
                       <a:solidFill>
                         <a:srgbClr val="CBD2D9"/>
@@ -9596,7 +9748,7 @@
                     <a:bodyPr/>
                     <a:lstStyle/>
                     <a:p>
-                      <a:pPr marL="0" indent="0">
+                      <a:pPr indent="0" marL="0">
                         <a:buNone/>
                       </a:pPr>
                       <a:r>
@@ -9617,7 +9769,7 @@
                       </a:endParaRPr>
                     </a:p>
                   </a:txBody>
-                  <a:tcPr anchor="ctr">
+                  <a:tcPr marL="91440" marR="91440" marT="45720" marB="45720" anchor="ctr">
                     <a:lnL w="6350" cap="flat" cmpd="sng" algn="ctr">
                       <a:solidFill>
                         <a:srgbClr val="CBD2D9"/>
@@ -9659,11 +9811,6 @@
                     </a:solidFill>
                   </a:tcPr>
                 </a:tc>
-                <a:extLst>
-                  <a:ext uri="{0D108BD9-81ED-4DB2-BD59-A6C34878D82A}">
-                    <a16:rowId xmlns:a16="http://schemas.microsoft.com/office/drawing/2014/main" val="10000"/>
-                  </a:ext>
-                </a:extLst>
               </a:tr>
               <a:tr h="530352">
                 <a:tc>
@@ -9671,7 +9818,7 @@
                     <a:bodyPr/>
                     <a:lstStyle/>
                     <a:p>
-                      <a:pPr marL="0" indent="0">
+                      <a:pPr indent="0" marL="0">
                         <a:buNone/>
                       </a:pPr>
                       <a:r>
@@ -9692,7 +9839,7 @@
                       </a:endParaRPr>
                     </a:p>
                   </a:txBody>
-                  <a:tcPr anchor="ctr">
+                  <a:tcPr marL="91440" marR="91440" marT="45720" marB="45720" anchor="ctr">
                     <a:lnL w="6350" cap="flat" cmpd="sng" algn="ctr">
                       <a:solidFill>
                         <a:srgbClr val="CBD2D9"/>
@@ -9736,7 +9883,7 @@
                     <a:bodyPr/>
                     <a:lstStyle/>
                     <a:p>
-                      <a:pPr marL="0" indent="0">
+                      <a:pPr indent="0" marL="0">
                         <a:buNone/>
                       </a:pPr>
                       <a:r>
@@ -9757,7 +9904,7 @@
                       </a:endParaRPr>
                     </a:p>
                   </a:txBody>
-                  <a:tcPr anchor="ctr">
+                  <a:tcPr marL="91440" marR="91440" marT="45720" marB="45720" anchor="ctr">
                     <a:lnL w="6350" cap="flat" cmpd="sng" algn="ctr">
                       <a:solidFill>
                         <a:srgbClr val="CBD2D9"/>
@@ -9801,7 +9948,7 @@
                     <a:bodyPr/>
                     <a:lstStyle/>
                     <a:p>
-                      <a:pPr marL="0" indent="0">
+                      <a:pPr indent="0" marL="0">
                         <a:buNone/>
                       </a:pPr>
                       <a:r>
@@ -9822,7 +9969,7 @@
                       </a:endParaRPr>
                     </a:p>
                   </a:txBody>
-                  <a:tcPr anchor="ctr">
+                  <a:tcPr marL="91440" marR="91440" marT="45720" marB="45720" anchor="ctr">
                     <a:lnL w="6350" cap="flat" cmpd="sng" algn="ctr">
                       <a:solidFill>
                         <a:srgbClr val="CBD2D9"/>
@@ -9866,7 +10013,7 @@
                     <a:bodyPr/>
                     <a:lstStyle/>
                     <a:p>
-                      <a:pPr marL="0" indent="0">
+                      <a:pPr indent="0" marL="0">
                         <a:buNone/>
                       </a:pPr>
                       <a:r>
@@ -9887,7 +10034,7 @@
                       </a:endParaRPr>
                     </a:p>
                   </a:txBody>
-                  <a:tcPr anchor="ctr">
+                  <a:tcPr marL="91440" marR="91440" marT="45720" marB="45720" anchor="ctr">
                     <a:lnL w="6350" cap="flat" cmpd="sng" algn="ctr">
                       <a:solidFill>
                         <a:srgbClr val="CBD2D9"/>
@@ -9926,11 +10073,6 @@
                     </a:lnB>
                   </a:tcPr>
                 </a:tc>
-                <a:extLst>
-                  <a:ext uri="{0D108BD9-81ED-4DB2-BD59-A6C34878D82A}">
-                    <a16:rowId xmlns:a16="http://schemas.microsoft.com/office/drawing/2014/main" val="10001"/>
-                  </a:ext>
-                </a:extLst>
               </a:tr>
               <a:tr h="530352">
                 <a:tc>
@@ -9938,7 +10080,7 @@
                     <a:bodyPr/>
                     <a:lstStyle/>
                     <a:p>
-                      <a:pPr marL="0" indent="0">
+                      <a:pPr indent="0" marL="0">
                         <a:buNone/>
                       </a:pPr>
                       <a:r>
@@ -9959,7 +10101,7 @@
                       </a:endParaRPr>
                     </a:p>
                   </a:txBody>
-                  <a:tcPr anchor="ctr">
+                  <a:tcPr marL="91440" marR="91440" marT="45720" marB="45720" anchor="ctr">
                     <a:lnL w="6350" cap="flat" cmpd="sng" algn="ctr">
                       <a:solidFill>
                         <a:srgbClr val="CBD2D9"/>
@@ -10003,7 +10145,7 @@
                     <a:bodyPr/>
                     <a:lstStyle/>
                     <a:p>
-                      <a:pPr marL="0" indent="0">
+                      <a:pPr indent="0" marL="0">
                         <a:buNone/>
                       </a:pPr>
                       <a:r>
@@ -10024,7 +10166,7 @@
                       </a:endParaRPr>
                     </a:p>
                   </a:txBody>
-                  <a:tcPr anchor="ctr">
+                  <a:tcPr marL="91440" marR="91440" marT="45720" marB="45720" anchor="ctr">
                     <a:lnL w="6350" cap="flat" cmpd="sng" algn="ctr">
                       <a:solidFill>
                         <a:srgbClr val="CBD2D9"/>
@@ -10068,7 +10210,7 @@
                     <a:bodyPr/>
                     <a:lstStyle/>
                     <a:p>
-                      <a:pPr marL="0" indent="0">
+                      <a:pPr indent="0" marL="0">
                         <a:buNone/>
                       </a:pPr>
                       <a:r>
@@ -10089,7 +10231,7 @@
                       </a:endParaRPr>
                     </a:p>
                   </a:txBody>
-                  <a:tcPr anchor="ctr">
+                  <a:tcPr marL="91440" marR="91440" marT="45720" marB="45720" anchor="ctr">
                     <a:lnL w="6350" cap="flat" cmpd="sng" algn="ctr">
                       <a:solidFill>
                         <a:srgbClr val="CBD2D9"/>
@@ -10133,7 +10275,7 @@
                     <a:bodyPr/>
                     <a:lstStyle/>
                     <a:p>
-                      <a:pPr marL="0" indent="0">
+                      <a:pPr indent="0" marL="0">
                         <a:buNone/>
                       </a:pPr>
                       <a:r>
@@ -10154,7 +10296,7 @@
                       </a:endParaRPr>
                     </a:p>
                   </a:txBody>
-                  <a:tcPr anchor="ctr">
+                  <a:tcPr marL="91440" marR="91440" marT="45720" marB="45720" anchor="ctr">
                     <a:lnL w="6350" cap="flat" cmpd="sng" algn="ctr">
                       <a:solidFill>
                         <a:srgbClr val="CBD2D9"/>
@@ -10193,11 +10335,6 @@
                     </a:lnB>
                   </a:tcPr>
                 </a:tc>
-                <a:extLst>
-                  <a:ext uri="{0D108BD9-81ED-4DB2-BD59-A6C34878D82A}">
-                    <a16:rowId xmlns:a16="http://schemas.microsoft.com/office/drawing/2014/main" val="10002"/>
-                  </a:ext>
-                </a:extLst>
               </a:tr>
               <a:tr h="530352">
                 <a:tc>
@@ -10205,7 +10342,7 @@
                     <a:bodyPr/>
                     <a:lstStyle/>
                     <a:p>
-                      <a:pPr marL="0" indent="0">
+                      <a:pPr indent="0" marL="0">
                         <a:buNone/>
                       </a:pPr>
                       <a:r>
@@ -10226,7 +10363,7 @@
                       </a:endParaRPr>
                     </a:p>
                   </a:txBody>
-                  <a:tcPr anchor="ctr">
+                  <a:tcPr marL="91440" marR="91440" marT="45720" marB="45720" anchor="ctr">
                     <a:lnL w="6350" cap="flat" cmpd="sng" algn="ctr">
                       <a:solidFill>
                         <a:srgbClr val="CBD2D9"/>
@@ -10270,7 +10407,7 @@
                     <a:bodyPr/>
                     <a:lstStyle/>
                     <a:p>
-                      <a:pPr marL="0" indent="0">
+                      <a:pPr indent="0" marL="0">
                         <a:buNone/>
                       </a:pPr>
                       <a:r>
@@ -10291,7 +10428,7 @@
                       </a:endParaRPr>
                     </a:p>
                   </a:txBody>
-                  <a:tcPr anchor="ctr">
+                  <a:tcPr marL="91440" marR="91440" marT="45720" marB="45720" anchor="ctr">
                     <a:lnL w="6350" cap="flat" cmpd="sng" algn="ctr">
                       <a:solidFill>
                         <a:srgbClr val="CBD2D9"/>
@@ -10335,7 +10472,7 @@
                     <a:bodyPr/>
                     <a:lstStyle/>
                     <a:p>
-                      <a:pPr marL="0" indent="0">
+                      <a:pPr indent="0" marL="0">
                         <a:buNone/>
                       </a:pPr>
                       <a:r>
@@ -10356,7 +10493,7 @@
                       </a:endParaRPr>
                     </a:p>
                   </a:txBody>
-                  <a:tcPr anchor="ctr">
+                  <a:tcPr marL="91440" marR="91440" marT="45720" marB="45720" anchor="ctr">
                     <a:lnL w="6350" cap="flat" cmpd="sng" algn="ctr">
                       <a:solidFill>
                         <a:srgbClr val="CBD2D9"/>
@@ -10400,7 +10537,7 @@
                     <a:bodyPr/>
                     <a:lstStyle/>
                     <a:p>
-                      <a:pPr marL="0" indent="0">
+                      <a:pPr indent="0" marL="0">
                         <a:buNone/>
                       </a:pPr>
                       <a:r>
@@ -10421,7 +10558,7 @@
                       </a:endParaRPr>
                     </a:p>
                   </a:txBody>
-                  <a:tcPr anchor="ctr">
+                  <a:tcPr marL="91440" marR="91440" marT="45720" marB="45720" anchor="ctr">
                     <a:lnL w="6350" cap="flat" cmpd="sng" algn="ctr">
                       <a:solidFill>
                         <a:srgbClr val="CBD2D9"/>
@@ -10460,11 +10597,6 @@
                     </a:lnB>
                   </a:tcPr>
                 </a:tc>
-                <a:extLst>
-                  <a:ext uri="{0D108BD9-81ED-4DB2-BD59-A6C34878D82A}">
-                    <a16:rowId xmlns:a16="http://schemas.microsoft.com/office/drawing/2014/main" val="10003"/>
-                  </a:ext>
-                </a:extLst>
               </a:tr>
               <a:tr h="530352">
                 <a:tc>
@@ -10472,7 +10604,7 @@
                     <a:bodyPr/>
                     <a:lstStyle/>
                     <a:p>
-                      <a:pPr marL="0" indent="0">
+                      <a:pPr indent="0" marL="0">
                         <a:buNone/>
                       </a:pPr>
                       <a:r>
@@ -10493,7 +10625,7 @@
                       </a:endParaRPr>
                     </a:p>
                   </a:txBody>
-                  <a:tcPr anchor="ctr">
+                  <a:tcPr marL="91440" marR="91440" marT="45720" marB="45720" anchor="ctr">
                     <a:lnL w="6350" cap="flat" cmpd="sng" algn="ctr">
                       <a:solidFill>
                         <a:srgbClr val="CBD2D9"/>
@@ -10537,7 +10669,7 @@
                     <a:bodyPr/>
                     <a:lstStyle/>
                     <a:p>
-                      <a:pPr marL="0" indent="0">
+                      <a:pPr indent="0" marL="0">
                         <a:buNone/>
                       </a:pPr>
                       <a:r>
@@ -10558,7 +10690,7 @@
                       </a:endParaRPr>
                     </a:p>
                   </a:txBody>
-                  <a:tcPr anchor="ctr">
+                  <a:tcPr marL="91440" marR="91440" marT="45720" marB="45720" anchor="ctr">
                     <a:lnL w="6350" cap="flat" cmpd="sng" algn="ctr">
                       <a:solidFill>
                         <a:srgbClr val="CBD2D9"/>
@@ -10602,7 +10734,7 @@
                     <a:bodyPr/>
                     <a:lstStyle/>
                     <a:p>
-                      <a:pPr marL="0" indent="0">
+                      <a:pPr indent="0" marL="0">
                         <a:buNone/>
                       </a:pPr>
                       <a:r>
@@ -10623,7 +10755,7 @@
                       </a:endParaRPr>
                     </a:p>
                   </a:txBody>
-                  <a:tcPr anchor="ctr">
+                  <a:tcPr marL="91440" marR="91440" marT="45720" marB="45720" anchor="ctr">
                     <a:lnL w="6350" cap="flat" cmpd="sng" algn="ctr">
                       <a:solidFill>
                         <a:srgbClr val="CBD2D9"/>
@@ -10667,7 +10799,7 @@
                     <a:bodyPr/>
                     <a:lstStyle/>
                     <a:p>
-                      <a:pPr marL="0" indent="0">
+                      <a:pPr indent="0" marL="0">
                         <a:buNone/>
                       </a:pPr>
                       <a:r>
@@ -10688,7 +10820,7 @@
                       </a:endParaRPr>
                     </a:p>
                   </a:txBody>
-                  <a:tcPr anchor="ctr">
+                  <a:tcPr marL="91440" marR="91440" marT="45720" marB="45720" anchor="ctr">
                     <a:lnL w="6350" cap="flat" cmpd="sng" algn="ctr">
                       <a:solidFill>
                         <a:srgbClr val="CBD2D9"/>
@@ -10727,11 +10859,6 @@
                     </a:lnB>
                   </a:tcPr>
                 </a:tc>
-                <a:extLst>
-                  <a:ext uri="{0D108BD9-81ED-4DB2-BD59-A6C34878D82A}">
-                    <a16:rowId xmlns:a16="http://schemas.microsoft.com/office/drawing/2014/main" val="10004"/>
-                  </a:ext>
-                </a:extLst>
               </a:tr>
             </a:tbl>
           </a:graphicData>
@@ -10758,7 +10885,7 @@
           <a:bodyPr wrap="square" lIns="0" tIns="0" rIns="0" bIns="0" rtlCol="0" anchor="t"/>
           <a:lstStyle/>
           <a:p>
-            <a:pPr marL="0" indent="0">
+            <a:pPr indent="0" marL="0">
               <a:buNone/>
             </a:pPr>
             <a:r>
@@ -10792,7 +10919,6 @@
         <a:solidFill>
           <a:srgbClr val="FFFFFF"/>
         </a:solidFill>
-        <a:effectLst/>
       </p:bgPr>
     </p:bg>
     <p:spTree>
@@ -10830,11 +10956,11 @@
           <a:bodyPr wrap="square" lIns="0" tIns="0" rIns="0" bIns="0" rtlCol="0" anchor="ctr"/>
           <a:lstStyle/>
           <a:p>
-            <a:pPr marL="0" indent="0">
+            <a:pPr indent="0" marL="0">
               <a:buNone/>
             </a:pPr>
             <a:r>
-              <a:rPr lang="en-US" sz="1100" b="1" kern="0" spc="300" dirty="0">
+              <a:rPr lang="en-US" sz="1100" b="1" spc="300" kern="0" dirty="0">
                 <a:solidFill>
                   <a:srgbClr val="0E7C86"/>
                 </a:solidFill>
@@ -10869,7 +10995,7 @@
           <a:bodyPr wrap="square" lIns="0" tIns="0" rIns="0" bIns="0" rtlCol="0" anchor="t"/>
           <a:lstStyle/>
           <a:p>
-            <a:pPr marL="0" indent="0">
+            <a:pPr indent="0" marL="0">
               <a:buNone/>
             </a:pPr>
             <a:r>
@@ -10908,7 +11034,7 @@
           <a:bodyPr wrap="square" lIns="0" tIns="0" rIns="0" bIns="0" rtlCol="0" anchor="t"/>
           <a:lstStyle/>
           <a:p>
-            <a:pPr marL="0" indent="0">
+            <a:pPr indent="0" marL="0">
               <a:buNone/>
             </a:pPr>
             <a:r>
@@ -10928,14 +11054,14 @@
       </p:sp>
       <p:pic>
         <p:nvPicPr>
-          <p:cNvPr id="5" name="Image 0" descr="/sessions/youthful-relaxed-maxwell/mnt/OHT_MAPF/results/assets/interval_cpp.png"/>
+          <p:cNvPr id="5" name="Image 0" descr="/sessions/youthful-relaxed-maxwell/mnt/OHT_MAPF/results/assets/interval_cpp.png">    </p:cNvPr>
           <p:cNvPicPr>
             <a:picLocks noChangeAspect="1"/>
           </p:cNvPicPr>
           <p:nvPr/>
         </p:nvPicPr>
         <p:blipFill>
-          <a:blip r:embed="rId3"/>
+          <a:blip r:embed="rId1"/>
           <a:stretch>
             <a:fillRect/>
           </a:stretch>
@@ -10966,7 +11092,6 @@
         <a:solidFill>
           <a:srgbClr val="FFFFFF"/>
         </a:solidFill>
-        <a:effectLst/>
       </p:bgPr>
     </p:bg>
     <p:spTree>
@@ -11004,11 +11129,11 @@
           <a:bodyPr wrap="square" lIns="0" tIns="0" rIns="0" bIns="0" rtlCol="0" anchor="ctr"/>
           <a:lstStyle/>
           <a:p>
-            <a:pPr marL="0" indent="0">
+            <a:pPr indent="0" marL="0">
               <a:buNone/>
             </a:pPr>
             <a:r>
-              <a:rPr lang="en-US" sz="1100" b="1" kern="0" spc="300" dirty="0">
+              <a:rPr lang="en-US" sz="1100" b="1" spc="300" kern="0" dirty="0">
                 <a:solidFill>
                   <a:srgbClr val="0E7C86"/>
                 </a:solidFill>
@@ -11043,7 +11168,7 @@
           <a:bodyPr wrap="square" lIns="0" tIns="0" rIns="0" bIns="0" rtlCol="0" anchor="t"/>
           <a:lstStyle/>
           <a:p>
-            <a:pPr marL="0" indent="0">
+            <a:pPr indent="0" marL="0">
               <a:buNone/>
             </a:pPr>
             <a:r>
@@ -11063,14 +11188,14 @@
       </p:sp>
       <p:pic>
         <p:nvPicPr>
-          <p:cNvPr id="4" name="Image 0" descr="/sessions/youthful-relaxed-maxwell/mnt/OHT_MAPF/results/assets/reservationTable_merge_left.png"/>
+          <p:cNvPr id="4" name="Image 0" descr="/sessions/youthful-relaxed-maxwell/mnt/OHT_MAPF/results/assets/reservationTable_merge_left.png">    </p:cNvPr>
           <p:cNvPicPr>
             <a:picLocks noChangeAspect="1"/>
           </p:cNvPicPr>
           <p:nvPr/>
         </p:nvPicPr>
         <p:blipFill>
-          <a:blip r:embed="rId3"/>
+          <a:blip r:embed="rId1"/>
           <a:stretch>
             <a:fillRect/>
           </a:stretch>
@@ -11106,7 +11231,7 @@
           <a:bodyPr wrap="square" lIns="0" tIns="0" rIns="0" bIns="0" rtlCol="0" anchor="ctr"/>
           <a:lstStyle/>
           <a:p>
-            <a:pPr marL="0" indent="0">
+            <a:pPr indent="0" marL="0">
               <a:buNone/>
             </a:pPr>
             <a:r>
@@ -11163,7 +11288,7 @@
             <a:endParaRPr lang="en-US" sz="1500" dirty="0"/>
           </a:p>
           <a:p>
-            <a:pPr marL="0" indent="0">
+            <a:pPr indent="0" marL="0">
               <a:spcAft>
                 <a:spcPts val="1000"/>
               </a:spcAft>
@@ -11201,7 +11326,7 @@
             <a:endParaRPr lang="en-US" sz="1500" dirty="0"/>
           </a:p>
           <a:p>
-            <a:pPr marL="0" indent="0">
+            <a:pPr indent="0" marL="0">
               <a:spcAft>
                 <a:spcPts val="1000"/>
               </a:spcAft>
@@ -11239,7 +11364,7 @@
             <a:endParaRPr lang="en-US" sz="1500" dirty="0"/>
           </a:p>
           <a:p>
-            <a:pPr marL="0" indent="0">
+            <a:pPr indent="0" marL="0">
               <a:buNone/>
             </a:pPr>
             <a:r>
@@ -11273,7 +11398,6 @@
         <a:solidFill>
           <a:srgbClr val="FFFFFF"/>
         </a:solidFill>
-        <a:effectLst/>
       </p:bgPr>
     </p:bg>
     <p:spTree>
@@ -11311,11 +11435,11 @@
           <a:bodyPr wrap="square" lIns="0" tIns="0" rIns="0" bIns="0" rtlCol="0" anchor="ctr"/>
           <a:lstStyle/>
           <a:p>
-            <a:pPr marL="0" indent="0">
+            <a:pPr indent="0" marL="0">
               <a:buNone/>
             </a:pPr>
             <a:r>
-              <a:rPr lang="en-US" sz="1100" b="1" kern="0" spc="300" dirty="0">
+              <a:rPr lang="en-US" sz="1100" b="1" spc="300" kern="0" dirty="0">
                 <a:solidFill>
                   <a:srgbClr val="0E7C86"/>
                 </a:solidFill>
@@ -11350,7 +11474,7 @@
           <a:bodyPr wrap="square" lIns="0" tIns="0" rIns="0" bIns="0" rtlCol="0" anchor="t"/>
           <a:lstStyle/>
           <a:p>
-            <a:pPr marL="0" indent="0">
+            <a:pPr indent="0" marL="0">
               <a:buNone/>
             </a:pPr>
             <a:r>
@@ -11389,7 +11513,7 @@
           <a:bodyPr wrap="square" lIns="0" tIns="0" rIns="0" bIns="0" rtlCol="0" anchor="t"/>
           <a:lstStyle/>
           <a:p>
-            <a:pPr marL="0" indent="0">
+            <a:pPr indent="0" marL="0">
               <a:buNone/>
             </a:pPr>
             <a:r>
@@ -11409,14 +11533,14 @@
       </p:sp>
       <p:pic>
         <p:nvPicPr>
-          <p:cNvPr id="5" name="Image 0" descr="/sessions/youthful-relaxed-maxwell/mnt/OHT_MAPF/results/assets/reservationTable_memory_1.png"/>
+          <p:cNvPr id="5" name="Image 0" descr="/sessions/youthful-relaxed-maxwell/mnt/OHT_MAPF/results/assets/reservationTable_memory_1.png">    </p:cNvPr>
           <p:cNvPicPr>
             <a:picLocks noChangeAspect="1"/>
           </p:cNvPicPr>
           <p:nvPr/>
         </p:nvPicPr>
         <p:blipFill>
-          <a:blip r:embed="rId3"/>
+          <a:blip r:embed="rId1"/>
           <a:stretch>
             <a:fillRect/>
           </a:stretch>
@@ -11452,7 +11576,7 @@
           <a:bodyPr wrap="square" lIns="0" tIns="0" rIns="0" bIns="0" rtlCol="0" anchor="ctr"/>
           <a:lstStyle/>
           <a:p>
-            <a:pPr marL="0" indent="0">
+            <a:pPr indent="0" marL="0">
               <a:buNone/>
             </a:pPr>
             <a:r>
@@ -11472,14 +11596,14 @@
       </p:sp>
       <p:pic>
         <p:nvPicPr>
-          <p:cNvPr id="7" name="Image 1" descr="/sessions/youthful-relaxed-maxwell/mnt/OHT_MAPF/results/assets/reservationTable_memory_2.png"/>
+          <p:cNvPr id="7" name="Image 1" descr="/sessions/youthful-relaxed-maxwell/mnt/OHT_MAPF/results/assets/reservationTable_memory_2.png">    </p:cNvPr>
           <p:cNvPicPr>
             <a:picLocks noChangeAspect="1"/>
           </p:cNvPicPr>
           <p:nvPr/>
         </p:nvPicPr>
         <p:blipFill>
-          <a:blip r:embed="rId4"/>
+          <a:blip r:embed="rId2"/>
           <a:stretch>
             <a:fillRect/>
           </a:stretch>
@@ -11515,7 +11639,7 @@
           <a:bodyPr wrap="square" lIns="0" tIns="0" rIns="0" bIns="0" rtlCol="0" anchor="ctr"/>
           <a:lstStyle/>
           <a:p>
-            <a:pPr marL="0" indent="0">
+            <a:pPr indent="0" marL="0">
               <a:buNone/>
             </a:pPr>
             <a:r>
@@ -11535,14 +11659,14 @@
       </p:sp>
       <p:pic>
         <p:nvPicPr>
-          <p:cNvPr id="9" name="Image 2" descr="/sessions/youthful-relaxed-maxwell/mnt/OHT_MAPF/results/assets/reservationTable_memory_3.png"/>
+          <p:cNvPr id="9" name="Image 2" descr="/sessions/youthful-relaxed-maxwell/mnt/OHT_MAPF/results/assets/reservationTable_memory_3.png">    </p:cNvPr>
           <p:cNvPicPr>
             <a:picLocks noChangeAspect="1"/>
           </p:cNvPicPr>
           <p:nvPr/>
         </p:nvPicPr>
         <p:blipFill>
-          <a:blip r:embed="rId5"/>
+          <a:blip r:embed="rId3"/>
           <a:stretch>
             <a:fillRect/>
           </a:stretch>
@@ -11578,7 +11702,7 @@
           <a:bodyPr wrap="square" lIns="0" tIns="0" rIns="0" bIns="0" rtlCol="0" anchor="ctr"/>
           <a:lstStyle/>
           <a:p>
-            <a:pPr marL="0" indent="0">
+            <a:pPr indent="0" marL="0">
               <a:buNone/>
             </a:pPr>
             <a:r>
@@ -11612,7 +11736,6 @@
         <a:solidFill>
           <a:srgbClr val="FFFFFF"/>
         </a:solidFill>
-        <a:effectLst/>
       </p:bgPr>
     </p:bg>
     <p:spTree>
@@ -11650,11 +11773,11 @@
           <a:bodyPr wrap="square" lIns="0" tIns="0" rIns="0" bIns="0" rtlCol="0" anchor="ctr"/>
           <a:lstStyle/>
           <a:p>
-            <a:pPr marL="0" indent="0">
+            <a:pPr indent="0" marL="0">
               <a:buNone/>
             </a:pPr>
             <a:r>
-              <a:rPr lang="en-US" sz="1100" b="1" kern="0" spc="300" dirty="0">
+              <a:rPr lang="en-US" sz="1100" b="1" spc="300" kern="0" dirty="0">
                 <a:solidFill>
                   <a:srgbClr val="0E7C86"/>
                 </a:solidFill>
@@ -11689,7 +11812,7 @@
           <a:bodyPr wrap="square" lIns="0" tIns="0" rIns="0" bIns="0" rtlCol="0" anchor="t"/>
           <a:lstStyle/>
           <a:p>
-            <a:pPr marL="0" indent="0">
+            <a:pPr indent="0" marL="0">
               <a:buNone/>
             </a:pPr>
             <a:r>
@@ -11728,7 +11851,7 @@
           <a:bodyPr wrap="square" lIns="0" tIns="0" rIns="0" bIns="0" rtlCol="0" anchor="t"/>
           <a:lstStyle/>
           <a:p>
-            <a:pPr marL="0" indent="0">
+            <a:pPr indent="0" marL="0">
               <a:buNone/>
             </a:pPr>
             <a:r>
@@ -11748,22 +11871,22 @@
       </p:sp>
       <p:pic>
         <p:nvPicPr>
-          <p:cNvPr id="5" name="Image 0" descr="/sessions/youthful-relaxed-maxwell/mnt/OHT_MAPF/results/assets/fig_minheap.png"/>
+          <p:cNvPr id="5" name="Image 0" descr="/sessions/youthful-relaxed-maxwell/mnt/OHT_MAPF/results/assets/fig_minheap.png">    </p:cNvPr>
           <p:cNvPicPr>
             <a:picLocks noChangeAspect="1"/>
           </p:cNvPicPr>
           <p:nvPr/>
         </p:nvPicPr>
         <p:blipFill>
-          <a:blip r:embed="rId3"/>
+          <a:blip r:embed="rId1"/>
           <a:stretch>
             <a:fillRect/>
           </a:stretch>
         </p:blipFill>
         <p:spPr>
           <a:xfrm>
-            <a:off x="2343299" y="2272337"/>
-            <a:ext cx="7505401" cy="4082743"/>
+            <a:off x="3055027" y="2606040"/>
+            <a:ext cx="6051466" cy="3291840"/>
           </a:xfrm>
           <a:prstGeom prst="rect">
             <a:avLst/>
@@ -11786,7 +11909,6 @@
         <a:solidFill>
           <a:srgbClr val="FFFFFF"/>
         </a:solidFill>
-        <a:effectLst/>
       </p:bgPr>
     </p:bg>
     <p:spTree>
@@ -11824,11 +11946,11 @@
           <a:bodyPr wrap="square" lIns="0" tIns="0" rIns="0" bIns="0" rtlCol="0" anchor="ctr"/>
           <a:lstStyle/>
           <a:p>
-            <a:pPr marL="0" indent="0">
+            <a:pPr indent="0" marL="0">
               <a:buNone/>
             </a:pPr>
             <a:r>
-              <a:rPr lang="en-US" sz="1100" b="1" kern="0" spc="300" dirty="0">
+              <a:rPr lang="en-US" sz="1100" b="1" spc="300" kern="0" dirty="0">
                 <a:solidFill>
                   <a:srgbClr val="0E7C86"/>
                 </a:solidFill>
@@ -11863,7 +11985,7 @@
           <a:bodyPr wrap="square" lIns="0" tIns="0" rIns="0" bIns="0" rtlCol="0" anchor="t"/>
           <a:lstStyle/>
           <a:p>
-            <a:pPr marL="0" indent="0">
+            <a:pPr indent="0" marL="0">
               <a:buNone/>
             </a:pPr>
             <a:r>
@@ -11902,7 +12024,7 @@
           <a:bodyPr wrap="square" lIns="0" tIns="0" rIns="0" bIns="0" rtlCol="0" anchor="t"/>
           <a:lstStyle/>
           <a:p>
-            <a:pPr marL="0" indent="0">
+            <a:pPr indent="0" marL="0">
               <a:buNone/>
             </a:pPr>
             <a:r>
@@ -11922,22 +12044,22 @@
       </p:sp>
       <p:pic>
         <p:nvPicPr>
-          <p:cNvPr id="5" name="Image 0" descr="/sessions/youthful-relaxed-maxwell/mnt/OHT_MAPF/results/assets/minheap.png"/>
+          <p:cNvPr id="5" name="Image 0" descr="/sessions/youthful-relaxed-maxwell/mnt/OHT_MAPF/results/assets/minheap.png">    </p:cNvPr>
           <p:cNvPicPr>
             <a:picLocks noChangeAspect="1"/>
           </p:cNvPicPr>
           <p:nvPr/>
         </p:nvPicPr>
         <p:blipFill>
-          <a:blip r:embed="rId3"/>
+          <a:blip r:embed="rId1"/>
           <a:stretch>
             <a:fillRect/>
           </a:stretch>
         </p:blipFill>
         <p:spPr>
           <a:xfrm>
-            <a:off x="4099937" y="2188254"/>
-            <a:ext cx="3992126" cy="4380908"/>
+            <a:off x="4205943" y="2377440"/>
+            <a:ext cx="3749634" cy="4114800"/>
           </a:xfrm>
           <a:prstGeom prst="rect">
             <a:avLst/>
@@ -11960,7 +12082,6 @@
         <a:solidFill>
           <a:srgbClr val="FFFFFF"/>
         </a:solidFill>
-        <a:effectLst/>
       </p:bgPr>
     </p:bg>
     <p:spTree>
@@ -11998,11 +12119,11 @@
           <a:bodyPr wrap="square" lIns="0" tIns="0" rIns="0" bIns="0" rtlCol="0" anchor="ctr"/>
           <a:lstStyle/>
           <a:p>
-            <a:pPr marL="0" indent="0">
+            <a:pPr indent="0" marL="0">
               <a:buNone/>
             </a:pPr>
             <a:r>
-              <a:rPr lang="en-US" sz="1100" b="1" kern="0" spc="300" dirty="0">
+              <a:rPr lang="en-US" sz="1100" b="1" spc="300" kern="0" dirty="0">
                 <a:solidFill>
                   <a:srgbClr val="0E7C86"/>
                 </a:solidFill>
@@ -12037,7 +12158,7 @@
           <a:bodyPr wrap="square" lIns="0" tIns="0" rIns="0" bIns="0" rtlCol="0" anchor="t"/>
           <a:lstStyle/>
           <a:p>
-            <a:pPr marL="0" indent="0">
+            <a:pPr indent="0" marL="0">
               <a:buNone/>
             </a:pPr>
             <a:r>
@@ -12076,7 +12197,7 @@
           <a:bodyPr wrap="square" lIns="0" tIns="0" rIns="0" bIns="0" rtlCol="0" anchor="t"/>
           <a:lstStyle/>
           <a:p>
-            <a:pPr marL="0" indent="0">
+            <a:pPr indent="0" marL="0">
               <a:buNone/>
             </a:pPr>
             <a:r>
@@ -12096,14 +12217,14 @@
       </p:sp>
       <p:pic>
         <p:nvPicPr>
-          <p:cNvPr id="5" name="Image 0" descr="/sessions/youthful-relaxed-maxwell/mnt/OHT_MAPF/results/assets/main_cpp_result.png"/>
+          <p:cNvPr id="5" name="Image 0" descr="/sessions/youthful-relaxed-maxwell/mnt/OHT_MAPF/results/assets/main_cpp_result.png">    </p:cNvPr>
           <p:cNvPicPr>
             <a:picLocks noChangeAspect="1"/>
           </p:cNvPicPr>
           <p:nvPr/>
         </p:nvPicPr>
         <p:blipFill>
-          <a:blip r:embed="rId3"/>
+          <a:blip r:embed="rId1"/>
           <a:stretch>
             <a:fillRect/>
           </a:stretch>
@@ -12134,7 +12255,6 @@
         <a:solidFill>
           <a:srgbClr val="1F2933"/>
         </a:solidFill>
-        <a:effectLst/>
       </p:bgPr>
     </p:bg>
     <p:spTree>
@@ -12172,9 +12292,20 @@
           <a:bodyPr wrap="square" lIns="0" tIns="0" rIns="0" bIns="0" rtlCol="0" anchor="ctr"/>
           <a:lstStyle/>
           <a:p>
-            <a:pPr marL="0" indent="0">
+            <a:pPr indent="0" marL="0">
               <a:buNone/>
             </a:pPr>
+            <a:r>
+              <a:rPr lang="en-US" sz="1100" b="1" spc="300" kern="0" dirty="0">
+                <a:solidFill>
+                  <a:srgbClr val="8FD3D8"/>
+                </a:solidFill>
+                <a:latin typeface="Calibri" pitchFamily="34" charset="0"/>
+                <a:ea typeface="Calibri" pitchFamily="34" charset="-122"/>
+                <a:cs typeface="Calibri" pitchFamily="34" charset="-120"/>
+              </a:rPr>
+              <a:t>CONCLUSION</a:t>
+            </a:r>
             <a:endParaRPr lang="en-US" sz="1100" dirty="0"/>
           </a:p>
         </p:txBody>
@@ -12200,14 +12331,14 @@
           <a:bodyPr wrap="square" lIns="0" tIns="0" rIns="0" bIns="0" rtlCol="0" anchor="ctr"/>
           <a:lstStyle/>
           <a:p>
-            <a:pPr marL="0" indent="0" algn="ctr">
+            <a:pPr indent="0" marL="0">
               <a:lnSpc>
                 <a:spcPct val="112000"/>
               </a:lnSpc>
               <a:buNone/>
             </a:pPr>
             <a:r>
-              <a:rPr lang="en-US" sz="5000" b="1" dirty="0">
+              <a:rPr lang="en-US" sz="3000" b="1" dirty="0">
                 <a:solidFill>
                   <a:srgbClr val="FFFFFF"/>
                 </a:solidFill>
@@ -12215,9 +12346,29 @@
                 <a:ea typeface="Georgia" pitchFamily="34" charset="-122"/>
                 <a:cs typeface="Georgia" pitchFamily="34" charset="-120"/>
               </a:rPr>
-              <a:t>Thank You</a:t>
-            </a:r>
-            <a:endParaRPr lang="en-US" sz="5000" dirty="0"/>
+              <a:t>Choosing the data structures is what</a:t>
+            </a:r>
+            <a:endParaRPr lang="en-US" sz="3000" dirty="0"/>
+          </a:p>
+          <a:p>
+            <a:pPr indent="0" marL="0">
+              <a:lnSpc>
+                <a:spcPct val="112000"/>
+              </a:lnSpc>
+              <a:buNone/>
+            </a:pPr>
+            <a:r>
+              <a:rPr lang="en-US" sz="3000" b="1" dirty="0">
+                <a:solidFill>
+                  <a:srgbClr val="FFFFFF"/>
+                </a:solidFill>
+                <a:latin typeface="Georgia" pitchFamily="34" charset="0"/>
+                <a:ea typeface="Georgia" pitchFamily="34" charset="-122"/>
+                <a:cs typeface="Georgia" pitchFamily="34" charset="-120"/>
+              </a:rPr>
+              <a:t>decides whether it works — and how far it scales.</a:t>
+            </a:r>
+            <a:endParaRPr lang="en-US" sz="3000" dirty="0"/>
           </a:p>
         </p:txBody>
       </p:sp>
@@ -12242,9 +12393,20 @@
           <a:bodyPr wrap="square" lIns="0" tIns="0" rIns="0" bIns="0" rtlCol="0" anchor="ctr"/>
           <a:lstStyle/>
           <a:p>
-            <a:pPr marL="0" indent="0">
+            <a:pPr indent="0" marL="0">
               <a:buNone/>
             </a:pPr>
+            <a:r>
+              <a:rPr lang="en-US" sz="1500" dirty="0">
+                <a:solidFill>
+                  <a:srgbClr val="CADCFC"/>
+                </a:solidFill>
+                <a:latin typeface="Calibri" pitchFamily="34" charset="0"/>
+                <a:ea typeface="Calibri" pitchFamily="34" charset="-122"/>
+                <a:cs typeface="Calibri" pitchFamily="34" charset="-120"/>
+              </a:rPr>
+              <a:t>Correctness rests on the reservation table's merge invariant; scale is bounded by data layout, not the search.</a:t>
+            </a:r>
             <a:endParaRPr lang="en-US" sz="1500" dirty="0"/>
           </a:p>
         </p:txBody>
@@ -12265,7 +12427,6 @@
         <a:solidFill>
           <a:srgbClr val="FFFFFF"/>
         </a:solidFill>
-        <a:effectLst/>
       </p:bgPr>
     </p:bg>
     <p:spTree>
@@ -12303,11 +12464,11 @@
           <a:bodyPr wrap="square" lIns="0" tIns="0" rIns="0" bIns="0" rtlCol="0" anchor="ctr"/>
           <a:lstStyle/>
           <a:p>
-            <a:pPr marL="0" indent="0">
+            <a:pPr indent="0" marL="0">
               <a:buNone/>
             </a:pPr>
             <a:r>
-              <a:rPr lang="en-US" sz="1100" b="1" kern="0" spc="300" dirty="0">
+              <a:rPr lang="en-US" sz="1100" b="1" spc="300" kern="0" dirty="0">
                 <a:solidFill>
                   <a:srgbClr val="0E7C86"/>
                 </a:solidFill>
@@ -12342,7 +12503,7 @@
           <a:bodyPr wrap="square" lIns="0" tIns="0" rIns="0" bIns="0" rtlCol="0" anchor="t"/>
           <a:lstStyle/>
           <a:p>
-            <a:pPr marL="0" indent="0">
+            <a:pPr indent="0" marL="0">
               <a:buNone/>
             </a:pPr>
             <a:r>
@@ -12381,7 +12542,7 @@
           <a:bodyPr wrap="square" lIns="0" tIns="0" rIns="0" bIns="0" rtlCol="0" anchor="t"/>
           <a:lstStyle/>
           <a:p>
-            <a:pPr marL="0" indent="0">
+            <a:pPr indent="0" marL="0">
               <a:buNone/>
             </a:pPr>
             <a:r>
@@ -12401,14 +12562,14 @@
       </p:sp>
       <p:pic>
         <p:nvPicPr>
-          <p:cNvPr id="5" name="Image 0" descr="/sessions/youthful-relaxed-maxwell/mnt/OHT_MAPF/results/assets/fig_motion.png"/>
+          <p:cNvPr id="5" name="Image 0" descr="/sessions/youthful-relaxed-maxwell/mnt/OHT_MAPF/results/assets/fig_motion.png">    </p:cNvPr>
           <p:cNvPicPr>
             <a:picLocks noChangeAspect="1"/>
           </p:cNvPicPr>
           <p:nvPr/>
         </p:nvPicPr>
         <p:blipFill>
-          <a:blip r:embed="rId3"/>
+          <a:blip r:embed="rId1"/>
           <a:stretch>
             <a:fillRect/>
           </a:stretch>
@@ -12439,7 +12600,6 @@
         <a:solidFill>
           <a:srgbClr val="FFFFFF"/>
         </a:solidFill>
-        <a:effectLst/>
       </p:bgPr>
     </p:bg>
     <p:spTree>
@@ -12477,11 +12637,11 @@
           <a:bodyPr wrap="square" lIns="0" tIns="0" rIns="0" bIns="0" rtlCol="0" anchor="ctr"/>
           <a:lstStyle/>
           <a:p>
-            <a:pPr marL="0" indent="0">
+            <a:pPr indent="0" marL="0">
               <a:buNone/>
             </a:pPr>
             <a:r>
-              <a:rPr lang="en-US" sz="1100" b="1" kern="0" spc="300" dirty="0">
+              <a:rPr lang="en-US" sz="1100" b="1" spc="300" kern="0" dirty="0">
                 <a:solidFill>
                   <a:srgbClr val="0E7C86"/>
                 </a:solidFill>
@@ -12516,7 +12676,7 @@
           <a:bodyPr wrap="square" lIns="0" tIns="0" rIns="0" bIns="0" rtlCol="0" anchor="t"/>
           <a:lstStyle/>
           <a:p>
-            <a:pPr marL="0" indent="0">
+            <a:pPr indent="0" marL="0">
               <a:buNone/>
             </a:pPr>
             <a:r>
@@ -12555,7 +12715,7 @@
           <a:bodyPr wrap="square" lIns="0" tIns="0" rIns="0" bIns="0" rtlCol="0" anchor="t"/>
           <a:lstStyle/>
           <a:p>
-            <a:pPr marL="0" indent="0">
+            <a:pPr indent="0" marL="0">
               <a:buNone/>
             </a:pPr>
             <a:r>
@@ -12575,14 +12735,14 @@
       </p:sp>
       <p:pic>
         <p:nvPicPr>
-          <p:cNvPr id="5" name="Image 0" descr="/sessions/youthful-relaxed-maxwell/mnt/OHT_MAPF/results/assets/fig_virtualnodes.png"/>
+          <p:cNvPr id="5" name="Image 0" descr="/sessions/youthful-relaxed-maxwell/mnt/OHT_MAPF/results/assets/fig_virtualnodes.png">    </p:cNvPr>
           <p:cNvPicPr>
             <a:picLocks noChangeAspect="1"/>
           </p:cNvPicPr>
           <p:nvPr/>
         </p:nvPicPr>
         <p:blipFill>
-          <a:blip r:embed="rId3"/>
+          <a:blip r:embed="rId1"/>
           <a:stretch>
             <a:fillRect/>
           </a:stretch>
@@ -12613,7 +12773,6 @@
         <a:solidFill>
           <a:srgbClr val="FFFFFF"/>
         </a:solidFill>
-        <a:effectLst/>
       </p:bgPr>
     </p:bg>
     <p:spTree>
@@ -12651,11 +12810,11 @@
           <a:bodyPr wrap="square" lIns="0" tIns="0" rIns="0" bIns="0" rtlCol="0" anchor="ctr"/>
           <a:lstStyle/>
           <a:p>
-            <a:pPr marL="0" indent="0">
+            <a:pPr indent="0" marL="0">
               <a:buNone/>
             </a:pPr>
             <a:r>
-              <a:rPr lang="en-US" sz="1100" b="1" kern="0" spc="300" dirty="0">
+              <a:rPr lang="en-US" sz="1100" b="1" spc="300" kern="0" dirty="0">
                 <a:solidFill>
                   <a:srgbClr val="0E7C86"/>
                 </a:solidFill>
@@ -12690,7 +12849,7 @@
           <a:bodyPr wrap="square" lIns="0" tIns="0" rIns="0" bIns="0" rtlCol="0" anchor="t"/>
           <a:lstStyle/>
           <a:p>
-            <a:pPr marL="0" indent="0">
+            <a:pPr indent="0" marL="0">
               <a:buNone/>
             </a:pPr>
             <a:r>
@@ -12710,14 +12869,14 @@
       </p:sp>
       <p:pic>
         <p:nvPicPr>
-          <p:cNvPr id="4" name="Image 0" descr="/sessions/youthful-relaxed-maxwell/mnt/OHT_MAPF/results/assets/fig_collision.png"/>
+          <p:cNvPr id="4" name="Image 0" descr="/sessions/youthful-relaxed-maxwell/mnt/OHT_MAPF/results/assets/fig_collision.png">    </p:cNvPr>
           <p:cNvPicPr>
             <a:picLocks noChangeAspect="1"/>
           </p:cNvPicPr>
           <p:nvPr/>
         </p:nvPicPr>
         <p:blipFill>
-          <a:blip r:embed="rId3"/>
+          <a:blip r:embed="rId1"/>
           <a:stretch>
             <a:fillRect/>
           </a:stretch>
@@ -12748,7 +12907,6 @@
         <a:solidFill>
           <a:srgbClr val="FFFFFF"/>
         </a:solidFill>
-        <a:effectLst/>
       </p:bgPr>
     </p:bg>
     <p:spTree>
@@ -12786,11 +12944,11 @@
           <a:bodyPr wrap="square" lIns="0" tIns="0" rIns="0" bIns="0" rtlCol="0" anchor="ctr"/>
           <a:lstStyle/>
           <a:p>
-            <a:pPr marL="0" indent="0">
+            <a:pPr indent="0" marL="0">
               <a:buNone/>
             </a:pPr>
             <a:r>
-              <a:rPr lang="en-US" sz="1100" b="1" kern="0" spc="300" dirty="0">
+              <a:rPr lang="en-US" sz="1100" b="1" spc="300" kern="0" dirty="0">
                 <a:solidFill>
                   <a:srgbClr val="0E7C86"/>
                 </a:solidFill>
@@ -12825,7 +12983,7 @@
           <a:bodyPr wrap="square" lIns="0" tIns="0" rIns="0" bIns="0" rtlCol="0" anchor="t"/>
           <a:lstStyle/>
           <a:p>
-            <a:pPr marL="0" indent="0">
+            <a:pPr indent="0" marL="0">
               <a:buNone/>
             </a:pPr>
             <a:r>
@@ -12864,7 +13022,7 @@
           <a:bodyPr wrap="square" lIns="0" tIns="0" rIns="0" bIns="0" rtlCol="0" anchor="t"/>
           <a:lstStyle/>
           <a:p>
-            <a:pPr marL="0" indent="0">
+            <a:pPr indent="0" marL="0">
               <a:buNone/>
             </a:pPr>
             <a:r>
@@ -12884,14 +13042,14 @@
       </p:sp>
       <p:pic>
         <p:nvPicPr>
-          <p:cNvPr id="5" name="Image 0" descr="/sessions/youthful-relaxed-maxwell/mnt/OHT_MAPF/results/assets/paper.png"/>
+          <p:cNvPr id="5" name="Image 0" descr="/sessions/youthful-relaxed-maxwell/mnt/OHT_MAPF/results/assets/paper.png">    </p:cNvPr>
           <p:cNvPicPr>
             <a:picLocks noChangeAspect="1"/>
           </p:cNvPicPr>
           <p:nvPr/>
         </p:nvPicPr>
         <p:blipFill>
-          <a:blip r:embed="rId3"/>
+          <a:blip r:embed="rId1"/>
           <a:stretch>
             <a:fillRect/>
           </a:stretch>
@@ -12908,14 +13066,14 @@
       </p:pic>
       <p:pic>
         <p:nvPicPr>
-          <p:cNvPr id="6" name="Image 1" descr="/sessions/youthful-relaxed-maxwell/mnt/OHT_MAPF/results/assets/github.png"/>
+          <p:cNvPr id="6" name="Image 1" descr="/sessions/youthful-relaxed-maxwell/mnt/OHT_MAPF/results/assets/github.png">    </p:cNvPr>
           <p:cNvPicPr>
             <a:picLocks noChangeAspect="1"/>
           </p:cNvPicPr>
           <p:nvPr/>
         </p:nvPicPr>
         <p:blipFill>
-          <a:blip r:embed="rId4"/>
+          <a:blip r:embed="rId2"/>
           <a:stretch>
             <a:fillRect/>
           </a:stretch>
@@ -12946,7 +13104,6 @@
         <a:solidFill>
           <a:srgbClr val="FFFFFF"/>
         </a:solidFill>
-        <a:effectLst/>
       </p:bgPr>
     </p:bg>
     <p:spTree>
@@ -12984,11 +13141,11 @@
           <a:bodyPr wrap="square" lIns="0" tIns="0" rIns="0" bIns="0" rtlCol="0" anchor="ctr"/>
           <a:lstStyle/>
           <a:p>
-            <a:pPr marL="0" indent="0">
+            <a:pPr indent="0" marL="0">
               <a:buNone/>
             </a:pPr>
             <a:r>
-              <a:rPr lang="en-US" sz="1100" b="1" kern="0" spc="300" dirty="0">
+              <a:rPr lang="en-US" sz="1100" b="1" spc="300" kern="0" dirty="0">
                 <a:solidFill>
                   <a:srgbClr val="0E7C86"/>
                 </a:solidFill>
@@ -13023,7 +13180,7 @@
           <a:bodyPr wrap="square" lIns="0" tIns="0" rIns="0" bIns="0" rtlCol="0" anchor="ctr"/>
           <a:lstStyle/>
           <a:p>
-            <a:pPr marL="0" indent="0">
+            <a:pPr indent="0" marL="0">
               <a:buNone/>
             </a:pPr>
             <a:r>
@@ -13037,6 +13194,9 @@
               </a:rPr>
               <a:t>Directed </a:t>
             </a:r>
+            <a:pPr indent="0" marL="0">
+              <a:buNone/>
+            </a:pPr>
             <a:r>
               <a:rPr lang="en-US" sz="3400" b="1" dirty="0">
                 <a:solidFill>
@@ -13048,6 +13208,9 @@
               </a:rPr>
               <a:t>weighted</a:t>
             </a:r>
+            <a:pPr indent="0" marL="0">
+              <a:buNone/>
+            </a:pPr>
             <a:r>
               <a:rPr lang="en-US" sz="3400" b="1" dirty="0">
                 <a:solidFill>
@@ -13084,7 +13247,7 @@
           <a:bodyPr wrap="square" lIns="0" tIns="0" rIns="0" bIns="0" rtlCol="0" anchor="ctr"/>
           <a:lstStyle/>
           <a:p>
-            <a:pPr marL="0" indent="0">
+            <a:pPr indent="0" marL="0">
               <a:buNone/>
             </a:pPr>
             <a:r>
@@ -13118,7 +13281,6 @@
         <a:solidFill>
           <a:srgbClr val="FFFFFF"/>
         </a:solidFill>
-        <a:effectLst/>
       </p:bgPr>
     </p:bg>
     <p:spTree>
@@ -13156,11 +13318,11 @@
           <a:bodyPr wrap="square" lIns="0" tIns="0" rIns="0" bIns="0" rtlCol="0" anchor="ctr"/>
           <a:lstStyle/>
           <a:p>
-            <a:pPr marL="0" indent="0">
+            <a:pPr indent="0" marL="0">
               <a:buNone/>
             </a:pPr>
             <a:r>
-              <a:rPr lang="en-US" sz="1100" b="1" kern="0" spc="300" dirty="0">
+              <a:rPr lang="en-US" sz="1100" b="1" spc="300" kern="0" dirty="0">
                 <a:solidFill>
                   <a:srgbClr val="0E7C86"/>
                 </a:solidFill>
@@ -13195,7 +13357,7 @@
           <a:bodyPr wrap="square" lIns="0" tIns="0" rIns="0" bIns="0" rtlCol="0" anchor="t"/>
           <a:lstStyle/>
           <a:p>
-            <a:pPr marL="0" indent="0">
+            <a:pPr indent="0" marL="0">
               <a:buNone/>
             </a:pPr>
             <a:r>
@@ -13234,7 +13396,7 @@
           <a:bodyPr wrap="square" lIns="0" tIns="0" rIns="0" bIns="0" rtlCol="0" anchor="t"/>
           <a:lstStyle/>
           <a:p>
-            <a:pPr marL="0" indent="0">
+            <a:pPr indent="0" marL="0">
               <a:buNone/>
             </a:pPr>
             <a:r>
@@ -13254,14 +13416,14 @@
       </p:sp>
       <p:pic>
         <p:nvPicPr>
-          <p:cNvPr id="5" name="Image 0" descr="/sessions/youthful-relaxed-maxwell/mnt/OHT_MAPF/results/assets/python_stage1_convert.png"/>
+          <p:cNvPr id="5" name="Image 0" descr="/sessions/youthful-relaxed-maxwell/mnt/OHT_MAPF/results/assets/python_stage1_convert.png">    </p:cNvPr>
           <p:cNvPicPr>
             <a:picLocks noChangeAspect="1"/>
           </p:cNvPicPr>
           <p:nvPr/>
         </p:nvPicPr>
         <p:blipFill>
-          <a:blip r:embed="rId3"/>
+          <a:blip r:embed="rId1"/>
           <a:stretch>
             <a:fillRect/>
           </a:stretch>
@@ -13292,7 +13454,6 @@
         <a:solidFill>
           <a:srgbClr val="FFFFFF"/>
         </a:solidFill>
-        <a:effectLst/>
       </p:bgPr>
     </p:bg>
     <p:spTree>
@@ -13330,11 +13491,11 @@
           <a:bodyPr wrap="square" lIns="0" tIns="0" rIns="0" bIns="0" rtlCol="0" anchor="ctr"/>
           <a:lstStyle/>
           <a:p>
-            <a:pPr marL="0" indent="0">
+            <a:pPr indent="0" marL="0">
               <a:buNone/>
             </a:pPr>
             <a:r>
-              <a:rPr lang="en-US" sz="1100" b="1" kern="0" spc="300" dirty="0">
+              <a:rPr lang="en-US" sz="1100" b="1" spc="300" kern="0" dirty="0">
                 <a:solidFill>
                   <a:srgbClr val="0E7C86"/>
                 </a:solidFill>
@@ -13369,7 +13530,7 @@
           <a:bodyPr wrap="square" lIns="0" tIns="0" rIns="0" bIns="0" rtlCol="0" anchor="t"/>
           <a:lstStyle/>
           <a:p>
-            <a:pPr marL="0" indent="0">
+            <a:pPr indent="0" marL="0">
               <a:buNone/>
             </a:pPr>
             <a:r>
@@ -13408,7 +13569,7 @@
           <a:bodyPr wrap="square" lIns="0" tIns="0" rIns="0" bIns="0" rtlCol="0" anchor="t"/>
           <a:lstStyle/>
           <a:p>
-            <a:pPr marL="0" indent="0">
+            <a:pPr indent="0" marL="0">
               <a:buNone/>
             </a:pPr>
             <a:r>
@@ -13428,14 +13589,14 @@
       </p:sp>
       <p:pic>
         <p:nvPicPr>
-          <p:cNvPr id="5" name="Image 0" descr="/sessions/youthful-relaxed-maxwell/mnt/OHT_MAPF/results/assets/python_stage2_expand.png"/>
+          <p:cNvPr id="5" name="Image 0" descr="/sessions/youthful-relaxed-maxwell/mnt/OHT_MAPF/results/assets/python_stage2_expand.png">    </p:cNvPr>
           <p:cNvPicPr>
             <a:picLocks noChangeAspect="1"/>
           </p:cNvPicPr>
           <p:nvPr/>
         </p:nvPicPr>
         <p:blipFill>
-          <a:blip r:embed="rId3"/>
+          <a:blip r:embed="rId1"/>
           <a:stretch>
             <a:fillRect/>
           </a:stretch>
@@ -13751,319 +13912,4 @@
     </a:ext>
   </a:extLst>
 </a:theme>
-</file>
-
-<file path=ppt/theme/theme2.xml><?xml version="1.0" encoding="utf-8"?>
-<a:theme xmlns:a="http://schemas.openxmlformats.org/drawingml/2006/main" name="Office 테마">
-  <a:themeElements>
-    <a:clrScheme name="Office">
-      <a:dk1>
-        <a:sysClr val="windowText" lastClr="000000"/>
-      </a:dk1>
-      <a:lt1>
-        <a:sysClr val="window" lastClr="FFFFFF"/>
-      </a:lt1>
-      <a:dk2>
-        <a:srgbClr val="0E2841"/>
-      </a:dk2>
-      <a:lt2>
-        <a:srgbClr val="E8E8E8"/>
-      </a:lt2>
-      <a:accent1>
-        <a:srgbClr val="156082"/>
-      </a:accent1>
-      <a:accent2>
-        <a:srgbClr val="E97132"/>
-      </a:accent2>
-      <a:accent3>
-        <a:srgbClr val="196B24"/>
-      </a:accent3>
-      <a:accent4>
-        <a:srgbClr val="0F9ED5"/>
-      </a:accent4>
-      <a:accent5>
-        <a:srgbClr val="A02B93"/>
-      </a:accent5>
-      <a:accent6>
-        <a:srgbClr val="4EA72E"/>
-      </a:accent6>
-      <a:hlink>
-        <a:srgbClr val="467886"/>
-      </a:hlink>
-      <a:folHlink>
-        <a:srgbClr val="96607D"/>
-      </a:folHlink>
-    </a:clrScheme>
-    <a:fontScheme name="Office">
-      <a:majorFont>
-        <a:latin typeface="맑은 고딕" panose="02110004020202020204"/>
-        <a:ea typeface=""/>
-        <a:cs typeface=""/>
-        <a:font script="Jpan" typeface="游ゴシック Light"/>
-        <a:font script="Hang" typeface="맑은 고딕"/>
-        <a:font script="Hans" typeface="等线 Light"/>
-        <a:font script="Hant" typeface="新細明體"/>
-        <a:font script="Arab" typeface="Times New Roman"/>
-        <a:font script="Hebr" typeface="Times New Roman"/>
-        <a:font script="Thai" typeface="Angsana New"/>
-        <a:font script="Ethi" typeface="Nyala"/>
-        <a:font script="Beng" typeface="Vrinda"/>
-        <a:font script="Gujr" typeface="Shruti"/>
-        <a:font script="Khmr" typeface="MoolBoran"/>
-        <a:font script="Knda" typeface="Tunga"/>
-        <a:font script="Guru" typeface="Raavi"/>
-        <a:font script="Cans" typeface="Euphemia"/>
-        <a:font script="Cher" typeface="Plantagenet Cherokee"/>
-        <a:font script="Yiii" typeface="Microsoft Yi Baiti"/>
-        <a:font script="Tibt" typeface="Microsoft Himalaya"/>
-        <a:font script="Thaa" typeface="MV Boli"/>
-        <a:font script="Deva" typeface="Mangal"/>
-        <a:font script="Telu" typeface="Gautami"/>
-        <a:font script="Taml" typeface="Latha"/>
-        <a:font script="Syrc" typeface="Estrangelo Edessa"/>
-        <a:font script="Orya" typeface="Kalinga"/>
-        <a:font script="Mlym" typeface="Kartika"/>
-        <a:font script="Laoo" typeface="DokChampa"/>
-        <a:font script="Sinh" typeface="Iskoola Pota"/>
-        <a:font script="Mong" typeface="Mongolian Baiti"/>
-        <a:font script="Viet" typeface="Times New Roman"/>
-        <a:font script="Uigh" typeface="Microsoft Uighur"/>
-        <a:font script="Geor" typeface="Sylfaen"/>
-        <a:font script="Armn" typeface="Arial"/>
-        <a:font script="Bugi" typeface="Leelawadee UI"/>
-        <a:font script="Bopo" typeface="Microsoft JhengHei"/>
-        <a:font script="Java" typeface="Javanese Text"/>
-        <a:font script="Lisu" typeface="Segoe UI"/>
-        <a:font script="Mymr" typeface="Myanmar Text"/>
-        <a:font script="Nkoo" typeface="Ebrima"/>
-        <a:font script="Olck" typeface="Nirmala UI"/>
-        <a:font script="Osma" typeface="Ebrima"/>
-        <a:font script="Phag" typeface="Phagspa"/>
-        <a:font script="Syrn" typeface="Estrangelo Edessa"/>
-        <a:font script="Syrj" typeface="Estrangelo Edessa"/>
-        <a:font script="Syre" typeface="Estrangelo Edessa"/>
-        <a:font script="Sora" typeface="Nirmala UI"/>
-        <a:font script="Tale" typeface="Microsoft Tai Le"/>
-        <a:font script="Talu" typeface="Microsoft New Tai Lue"/>
-        <a:font script="Tfng" typeface="Ebrima"/>
-      </a:majorFont>
-      <a:minorFont>
-        <a:latin typeface="맑은 고딕" panose="02110004020202020204"/>
-        <a:ea typeface=""/>
-        <a:cs typeface=""/>
-        <a:font script="Jpan" typeface="游ゴシック"/>
-        <a:font script="Hang" typeface="맑은 고딕"/>
-        <a:font script="Hans" typeface="等线"/>
-        <a:font script="Hant" typeface="新細明體"/>
-        <a:font script="Arab" typeface="Arial"/>
-        <a:font script="Hebr" typeface="Arial"/>
-        <a:font script="Thai" typeface="Cordia New"/>
-        <a:font script="Ethi" typeface="Nyala"/>
-        <a:font script="Beng" typeface="Vrinda"/>
-        <a:font script="Gujr" typeface="Shruti"/>
-        <a:font script="Khmr" typeface="DaunPenh"/>
-        <a:font script="Knda" typeface="Tunga"/>
-        <a:font script="Guru" typeface="Raavi"/>
-        <a:font script="Cans" typeface="Euphemia"/>
-        <a:font script="Cher" typeface="Plantagenet Cherokee"/>
-        <a:font script="Yiii" typeface="Microsoft Yi Baiti"/>
-        <a:font script="Tibt" typeface="Microsoft Himalaya"/>
-        <a:font script="Thaa" typeface="MV Boli"/>
-        <a:font script="Deva" typeface="Mangal"/>
-        <a:font script="Telu" typeface="Gautami"/>
-        <a:font script="Taml" typeface="Latha"/>
-        <a:font script="Syrc" typeface="Estrangelo Edessa"/>
-        <a:font script="Orya" typeface="Kalinga"/>
-        <a:font script="Mlym" typeface="Kartika"/>
-        <a:font script="Laoo" typeface="DokChampa"/>
-        <a:font script="Sinh" typeface="Iskoola Pota"/>
-        <a:font script="Mong" typeface="Mongolian Baiti"/>
-        <a:font script="Viet" typeface="Arial"/>
-        <a:font script="Uigh" typeface="Microsoft Uighur"/>
-        <a:font script="Geor" typeface="Sylfaen"/>
-        <a:font script="Armn" typeface="Arial"/>
-        <a:font script="Bugi" typeface="Leelawadee UI"/>
-        <a:font script="Bopo" typeface="Microsoft JhengHei"/>
-        <a:font script="Java" typeface="Javanese Text"/>
-        <a:font script="Lisu" typeface="Segoe UI"/>
-        <a:font script="Mymr" typeface="Myanmar Text"/>
-        <a:font script="Nkoo" typeface="Ebrima"/>
-        <a:font script="Olck" typeface="Nirmala UI"/>
-        <a:font script="Osma" typeface="Ebrima"/>
-        <a:font script="Phag" typeface="Phagspa"/>
-        <a:font script="Syrn" typeface="Estrangelo Edessa"/>
-        <a:font script="Syrj" typeface="Estrangelo Edessa"/>
-        <a:font script="Syre" typeface="Estrangelo Edessa"/>
-        <a:font script="Sora" typeface="Nirmala UI"/>
-        <a:font script="Tale" typeface="Microsoft Tai Le"/>
-        <a:font script="Talu" typeface="Microsoft New Tai Lue"/>
-        <a:font script="Tfng" typeface="Ebrima"/>
-      </a:minorFont>
-    </a:fontScheme>
-    <a:fmtScheme name="Office">
-      <a:fillStyleLst>
-        <a:solidFill>
-          <a:schemeClr val="phClr"/>
-        </a:solidFill>
-        <a:gradFill rotWithShape="1">
-          <a:gsLst>
-            <a:gs pos="0">
-              <a:schemeClr val="phClr">
-                <a:lumMod val="110000"/>
-                <a:satMod val="105000"/>
-                <a:tint val="67000"/>
-              </a:schemeClr>
-            </a:gs>
-            <a:gs pos="50000">
-              <a:schemeClr val="phClr">
-                <a:lumMod val="105000"/>
-                <a:satMod val="103000"/>
-                <a:tint val="73000"/>
-              </a:schemeClr>
-            </a:gs>
-            <a:gs pos="100000">
-              <a:schemeClr val="phClr">
-                <a:lumMod val="105000"/>
-                <a:satMod val="109000"/>
-                <a:tint val="81000"/>
-              </a:schemeClr>
-            </a:gs>
-          </a:gsLst>
-          <a:lin ang="5400000" scaled="0"/>
-        </a:gradFill>
-        <a:gradFill rotWithShape="1">
-          <a:gsLst>
-            <a:gs pos="0">
-              <a:schemeClr val="phClr">
-                <a:satMod val="103000"/>
-                <a:lumMod val="102000"/>
-                <a:tint val="94000"/>
-              </a:schemeClr>
-            </a:gs>
-            <a:gs pos="50000">
-              <a:schemeClr val="phClr">
-                <a:satMod val="110000"/>
-                <a:lumMod val="100000"/>
-                <a:shade val="100000"/>
-              </a:schemeClr>
-            </a:gs>
-            <a:gs pos="100000">
-              <a:schemeClr val="phClr">
-                <a:lumMod val="99000"/>
-                <a:satMod val="120000"/>
-                <a:shade val="78000"/>
-              </a:schemeClr>
-            </a:gs>
-          </a:gsLst>
-          <a:lin ang="5400000" scaled="0"/>
-        </a:gradFill>
-      </a:fillStyleLst>
-      <a:lnStyleLst>
-        <a:ln w="12700" cap="flat" cmpd="sng" algn="ctr">
-          <a:solidFill>
-            <a:schemeClr val="phClr"/>
-          </a:solidFill>
-          <a:prstDash val="solid"/>
-          <a:miter lim="800000"/>
-        </a:ln>
-        <a:ln w="19050" cap="flat" cmpd="sng" algn="ctr">
-          <a:solidFill>
-            <a:schemeClr val="phClr"/>
-          </a:solidFill>
-          <a:prstDash val="solid"/>
-          <a:miter lim="800000"/>
-        </a:ln>
-        <a:ln w="25400" cap="flat" cmpd="sng" algn="ctr">
-          <a:solidFill>
-            <a:schemeClr val="phClr"/>
-          </a:solidFill>
-          <a:prstDash val="solid"/>
-          <a:miter lim="800000"/>
-        </a:ln>
-      </a:lnStyleLst>
-      <a:effectStyleLst>
-        <a:effectStyle>
-          <a:effectLst/>
-        </a:effectStyle>
-        <a:effectStyle>
-          <a:effectLst/>
-        </a:effectStyle>
-        <a:effectStyle>
-          <a:effectLst>
-            <a:outerShdw blurRad="57150" dist="19050" dir="5400000" algn="ctr" rotWithShape="0">
-              <a:srgbClr val="000000">
-                <a:alpha val="63000"/>
-              </a:srgbClr>
-            </a:outerShdw>
-          </a:effectLst>
-        </a:effectStyle>
-      </a:effectStyleLst>
-      <a:bgFillStyleLst>
-        <a:solidFill>
-          <a:schemeClr val="phClr"/>
-        </a:solidFill>
-        <a:solidFill>
-          <a:schemeClr val="phClr">
-            <a:tint val="95000"/>
-            <a:satMod val="170000"/>
-          </a:schemeClr>
-        </a:solidFill>
-        <a:gradFill rotWithShape="1">
-          <a:gsLst>
-            <a:gs pos="0">
-              <a:schemeClr val="phClr">
-                <a:tint val="93000"/>
-                <a:satMod val="150000"/>
-                <a:shade val="98000"/>
-                <a:lumMod val="102000"/>
-              </a:schemeClr>
-            </a:gs>
-            <a:gs pos="50000">
-              <a:schemeClr val="phClr">
-                <a:tint val="98000"/>
-                <a:satMod val="130000"/>
-                <a:shade val="90000"/>
-                <a:lumMod val="103000"/>
-              </a:schemeClr>
-            </a:gs>
-            <a:gs pos="100000">
-              <a:schemeClr val="phClr">
-                <a:shade val="63000"/>
-                <a:satMod val="120000"/>
-              </a:schemeClr>
-            </a:gs>
-          </a:gsLst>
-          <a:lin ang="5400000" scaled="0"/>
-        </a:gradFill>
-      </a:bgFillStyleLst>
-    </a:fmtScheme>
-  </a:themeElements>
-  <a:objectDefaults>
-    <a:lnDef>
-      <a:spPr/>
-      <a:bodyPr/>
-      <a:lstStyle/>
-      <a:style>
-        <a:lnRef idx="2">
-          <a:schemeClr val="accent1"/>
-        </a:lnRef>
-        <a:fillRef idx="0">
-          <a:schemeClr val="accent1"/>
-        </a:fillRef>
-        <a:effectRef idx="1">
-          <a:schemeClr val="accent1"/>
-        </a:effectRef>
-        <a:fontRef idx="minor">
-          <a:schemeClr val="tx1"/>
-        </a:fontRef>
-      </a:style>
-    </a:lnDef>
-  </a:objectDefaults>
-  <a:extraClrSchemeLst/>
-  <a:extLst>
-    <a:ext uri="{05A4C25C-085E-4340-85A3-A5531E510DB2}">
-      <thm15:themeFamily xmlns:thm15="http://schemas.microsoft.com/office/thememl/2012/main" name="Office Theme" id="{2E142A2C-CD16-42D6-873A-C26D2A0506FA}" vid="{1BDDFF52-6CD6-40A5-AB3C-68EB2F1E4D0A}"/>
-    </a:ext>
-  </a:extLst>
-</a:theme>
 </file>
</xml_diff>